<commit_message>
Polish naming and chapter badge semantics in generator
Agent-Logs-Url: https://github.com/ltx-202432110105/quote/sessions/ff0e0d8b-989a-4c83-8caf-e13c1c562c98

Co-authored-by: ltx-202432110105 <206035505+ltx-202432110105@users.noreply.github.com>
</commit_message>
<xml_diff>
--- a/slides/competition.pptx
+++ b/slides/competition.pptx
@@ -5761,7 +5761,7 @@
                 </a:solidFill>
                 <a:latin typeface="Microsoft YaHei"/>
               </a:rPr>
-              <a:t>SECTION 6</a:t>
+              <a:t>PAGE 6</a:t>
             </a:r>
           </a:p>
         </p:txBody>
@@ -38025,7 +38025,7 @@
                 </a:solidFill>
                 <a:latin typeface="Microsoft YaHei"/>
               </a:rPr>
-              <a:t>SECTION 17</a:t>
+              <a:t>PAGE 17</a:t>
             </a:r>
           </a:p>
         </p:txBody>

</xml_diff>

<commit_message>
Align chapter badge matching and panel label language
Agent-Logs-Url: https://github.com/ltx-202432110105/quote/sessions/ff0e0d8b-989a-4c83-8caf-e13c1c562c98

Co-authored-by: ltx-202432110105 <206035505+ltx-202432110105@users.noreply.github.com>
</commit_message>
<xml_diff>
--- a/slides/competition.pptx
+++ b/slides/competition.pptx
@@ -13577,7 +13577,7 @@
                 </a:solidFill>
                 <a:latin typeface="Microsoft YaHei"/>
               </a:rPr>
-              <a:t>TECH PANEL</a:t>
+              <a:t>技术面板</a:t>
             </a:r>
           </a:p>
         </p:txBody>
@@ -15696,7 +15696,7 @@
                 </a:solidFill>
                 <a:latin typeface="Microsoft YaHei"/>
               </a:rPr>
-              <a:t>TECH PANEL</a:t>
+              <a:t>技术面板</a:t>
             </a:r>
           </a:p>
         </p:txBody>
@@ -16831,7 +16831,7 @@
                 </a:solidFill>
                 <a:latin typeface="Microsoft YaHei"/>
               </a:rPr>
-              <a:t>TECH PANEL</a:t>
+              <a:t>技术面板</a:t>
             </a:r>
           </a:p>
         </p:txBody>
@@ -28076,7 +28076,7 @@
                 </a:solidFill>
                 <a:latin typeface="Microsoft YaHei"/>
               </a:rPr>
-              <a:t>TECH PANEL</a:t>
+              <a:t>技术面板</a:t>
             </a:r>
           </a:p>
         </p:txBody>
@@ -35588,7 +35588,7 @@
                 </a:solidFill>
                 <a:latin typeface="Microsoft YaHei"/>
               </a:rPr>
-              <a:t>TECH PANEL</a:t>
+              <a:t>技术面板</a:t>
             </a:r>
           </a:p>
         </p:txBody>
@@ -49662,7 +49662,7 @@
                 </a:solidFill>
                 <a:latin typeface="Microsoft YaHei"/>
               </a:rPr>
-              <a:t>TECH PANEL</a:t>
+              <a:t>技术面板</a:t>
             </a:r>
           </a:p>
         </p:txBody>

</xml_diff>

<commit_message>
Polish tech-tag extraction and pin attribution asset URLs
Agent-Logs-Url: https://github.com/ltx-202432110105/quote/sessions/f0639ab5-8390-4182-b4e5-66658a9832aa

Co-authored-by: ltx-202432110105 <206035505+ltx-202432110105@users.noreply.github.com>
</commit_message>
<xml_diff>
--- a/slides/competition.pptx
+++ b/slides/competition.pptx
@@ -5071,7 +5071,7 @@
                 </a:solidFill>
                 <a:latin typeface="Microsoft YaHei"/>
               </a:rPr>
-              <a:t>MYSQL</a:t>
+              <a:t>GIN</a:t>
             </a:r>
           </a:p>
         </p:txBody>
@@ -5188,7 +5188,7 @@
       </p:pic>
       <p:pic>
         <p:nvPicPr>
-          <p:cNvPr id="50" name="Picture 49" descr="mysql.png"/>
+          <p:cNvPr id="50" name="Picture 49" descr="docker.png"/>
           <p:cNvPicPr>
             <a:picLocks noChangeAspect="1"/>
           </p:cNvPicPr>
@@ -5212,7 +5212,7 @@
       </p:pic>
       <p:pic>
         <p:nvPicPr>
-          <p:cNvPr id="51" name="Picture 50" descr="redis.png"/>
+          <p:cNvPr id="51" name="Picture 50" descr="mysql.png"/>
           <p:cNvPicPr>
             <a:picLocks noChangeAspect="1"/>
           </p:cNvPicPr>
@@ -5236,7 +5236,7 @@
       </p:pic>
       <p:pic>
         <p:nvPicPr>
-          <p:cNvPr id="52" name="Picture 51" descr="github.png"/>
+          <p:cNvPr id="52" name="Picture 51" descr="redis.png"/>
           <p:cNvPicPr>
             <a:picLocks noChangeAspect="1"/>
           </p:cNvPicPr>

</xml_diff>

<commit_message>
Unify tech display labels and genericize fallback stack copy
Agent-Logs-Url: https://github.com/ltx-202432110105/quote/sessions/f0639ab5-8390-4182-b4e5-66658a9832aa

Co-authored-by: ltx-202432110105 <206035505+ltx-202432110105@users.noreply.github.com>
</commit_message>
<xml_diff>
--- a/slides/competition.pptx
+++ b/slides/competition.pptx
@@ -5071,7 +5071,7 @@
                 </a:solidFill>
                 <a:latin typeface="Microsoft YaHei"/>
               </a:rPr>
-              <a:t>GIN</a:t>
+              <a:t>DOCKER</a:t>
             </a:r>
           </a:p>
         </p:txBody>
@@ -35068,7 +35068,7 @@
                 </a:solidFill>
                 <a:latin typeface="Microsoft YaHei"/>
               </a:rPr>
-              <a:t>GO-ZERO</a:t>
+              <a:t>MYSQL</a:t>
             </a:r>
           </a:p>
         </p:txBody>

</xml_diff>

<commit_message>
Upgrade backgrounds to richer licensed tech scenes with layout rotation
Agent-Logs-Url: https://github.com/ltx-202432110105/quote/sessions/03200f01-9855-45ae-be53-5cdf70d482fe

Co-authored-by: ltx-202432110105 <206035505+ltx-202432110105@users.noreply.github.com>
</commit_message>
<xml_diff>
--- a/slides/competition.pptx
+++ b/slides/competition.pptx
@@ -3117,7 +3117,7 @@
       <p:grpSpPr/>
       <p:pic>
         <p:nvPicPr>
-          <p:cNvPr id="2" name="Picture 1" descr="tech-bg-1.jpg"/>
+          <p:cNvPr id="2" name="Picture 1" descr="scene-01.jpg"/>
           <p:cNvPicPr>
             <a:picLocks noChangeAspect="1"/>
           </p:cNvPicPr>
@@ -5310,7 +5310,7 @@
       <p:grpSpPr/>
       <p:pic>
         <p:nvPicPr>
-          <p:cNvPr id="2" name="Picture 1" descr="tech-bg-2.jpg"/>
+          <p:cNvPr id="2" name="Picture 1" descr="scene-10.jpg"/>
           <p:cNvPicPr>
             <a:picLocks noChangeAspect="1"/>
           </p:cNvPicPr>
@@ -5324,8 +5324,8 @@
         </p:blipFill>
         <p:spPr>
           <a:xfrm>
-            <a:off x="0" y="0"/>
-            <a:ext cx="12191695" cy="6858000"/>
+            <a:off x="7818120" y="0"/>
+            <a:ext cx="4370832" cy="6858000"/>
           </a:xfrm>
           <a:prstGeom prst="rect">
             <a:avLst/>
@@ -5340,8 +5340,8 @@
         </p:nvSpPr>
         <p:spPr>
           <a:xfrm>
-            <a:off x="0" y="0"/>
-            <a:ext cx="12191695" cy="6858000"/>
+            <a:off x="7699248" y="0"/>
+            <a:ext cx="4526280" cy="6858000"/>
           </a:xfrm>
           <a:prstGeom prst="rect">
             <a:avLst/>
@@ -7657,7 +7657,7 @@
       <p:grpSpPr/>
       <p:pic>
         <p:nvPicPr>
-          <p:cNvPr id="2" name="Picture 1" descr="tech-bg-3.jpg"/>
+          <p:cNvPr id="2" name="Picture 1" descr="scene-11.jpg"/>
           <p:cNvPicPr>
             <a:picLocks noChangeAspect="1"/>
           </p:cNvPicPr>
@@ -9695,7 +9695,7 @@
       <p:grpSpPr/>
       <p:pic>
         <p:nvPicPr>
-          <p:cNvPr id="2" name="Picture 1" descr="tech-bg-4.jpg"/>
+          <p:cNvPr id="2" name="Picture 1" descr="scene-12.jpg"/>
           <p:cNvPicPr>
             <a:picLocks noChangeAspect="1"/>
           </p:cNvPicPr>
@@ -9709,28 +9709,114 @@
         </p:blipFill>
         <p:spPr>
           <a:xfrm>
+            <a:off x="4754880" y="0"/>
+            <a:ext cx="7452360" cy="6858000"/>
+          </a:xfrm>
+          <a:prstGeom prst="rect">
+            <a:avLst/>
+          </a:prstGeom>
+        </p:spPr>
+      </p:pic>
+      <p:sp>
+        <p:nvSpPr>
+          <p:cNvPr id="3" name="Chevron 2"/>
+          <p:cNvSpPr/>
+          <p:nvPr/>
+        </p:nvSpPr>
+        <p:spPr>
+          <a:xfrm>
+            <a:off x="4434840" y="45720"/>
+            <a:ext cx="2423160" cy="6720840"/>
+          </a:xfrm>
+          <a:prstGeom prst="chevron">
+            <a:avLst/>
+          </a:prstGeom>
+          <a:solidFill>
+            <a:srgbClr val="E6EEFA"/>
+          </a:solidFill>
+          <a:ln>
+            <a:noFill/>
+          </a:ln>
+        </p:spPr>
+        <p:style>
+          <a:lnRef idx="1">
+            <a:schemeClr val="accent1"/>
+          </a:lnRef>
+          <a:fillRef idx="3">
+            <a:schemeClr val="accent1"/>
+          </a:fillRef>
+          <a:effectRef idx="2">
+            <a:schemeClr val="accent1"/>
+          </a:effectRef>
+          <a:fontRef idx="minor">
+            <a:schemeClr val="lt1"/>
+          </a:fontRef>
+        </p:style>
+        <p:txBody>
+          <a:bodyPr rtlCol="0" anchor="ctr"/>
+          <a:lstStyle/>
+          <a:p>
+            <a:pPr algn="ctr"/>
+          </a:p>
+        </p:txBody>
+      </p:sp>
+      <p:sp>
+        <p:nvSpPr>
+          <p:cNvPr id="4" name="Rectangle 3"/>
+          <p:cNvSpPr/>
+          <p:nvPr/>
+        </p:nvSpPr>
+        <p:spPr>
+          <a:xfrm>
+            <a:off x="4663440" y="0"/>
+            <a:ext cx="7543800" cy="6858000"/>
+          </a:xfrm>
+          <a:prstGeom prst="rect">
+            <a:avLst/>
+          </a:prstGeom>
+          <a:solidFill>
+            <a:srgbClr val="FFFFFF"/>
+          </a:solidFill>
+          <a:ln>
+            <a:noFill/>
+          </a:ln>
+        </p:spPr>
+        <p:style>
+          <a:lnRef idx="1">
+            <a:schemeClr val="accent1"/>
+          </a:lnRef>
+          <a:fillRef idx="3">
+            <a:schemeClr val="accent1"/>
+          </a:fillRef>
+          <a:effectRef idx="2">
+            <a:schemeClr val="accent1"/>
+          </a:effectRef>
+          <a:fontRef idx="minor">
+            <a:schemeClr val="lt1"/>
+          </a:fontRef>
+        </p:style>
+        <p:txBody>
+          <a:bodyPr rtlCol="0" anchor="ctr"/>
+          <a:lstStyle/>
+          <a:p>
+            <a:pPr algn="ctr"/>
+          </a:p>
+        </p:txBody>
+      </p:sp>
+      <p:sp>
+        <p:nvSpPr>
+          <p:cNvPr id="5" name="Rectangle 4"/>
+          <p:cNvSpPr/>
+          <p:nvPr/>
+        </p:nvSpPr>
+        <p:spPr>
+          <a:xfrm>
             <a:off x="0" y="0"/>
             <a:ext cx="12191695" cy="6858000"/>
           </a:xfrm>
           <a:prstGeom prst="rect">
             <a:avLst/>
           </a:prstGeom>
-        </p:spPr>
-      </p:pic>
-      <p:sp>
-        <p:nvSpPr>
-          <p:cNvPr id="3" name="Rectangle 2"/>
-          <p:cNvSpPr/>
-          <p:nvPr/>
-        </p:nvSpPr>
-        <p:spPr>
-          <a:xfrm>
-            <a:off x="0" y="0"/>
-            <a:ext cx="12191695" cy="6858000"/>
-          </a:xfrm>
-          <a:prstGeom prst="rect">
-            <a:avLst/>
-          </a:prstGeom>
           <a:solidFill>
             <a:srgbClr val="FFFFFF"/>
           </a:solidFill>
@@ -9762,50 +9848,7 @@
       </p:sp>
       <p:sp>
         <p:nvSpPr>
-          <p:cNvPr id="4" name="Rectangle 3"/>
-          <p:cNvSpPr/>
-          <p:nvPr/>
-        </p:nvSpPr>
-        <p:spPr>
-          <a:xfrm>
-            <a:off x="0" y="0"/>
-            <a:ext cx="12191695" cy="6858000"/>
-          </a:xfrm>
-          <a:prstGeom prst="rect">
-            <a:avLst/>
-          </a:prstGeom>
-          <a:solidFill>
-            <a:srgbClr val="FFFFFF"/>
-          </a:solidFill>
-          <a:ln>
-            <a:noFill/>
-          </a:ln>
-        </p:spPr>
-        <p:style>
-          <a:lnRef idx="1">
-            <a:schemeClr val="accent1"/>
-          </a:lnRef>
-          <a:fillRef idx="3">
-            <a:schemeClr val="accent1"/>
-          </a:fillRef>
-          <a:effectRef idx="2">
-            <a:schemeClr val="accent1"/>
-          </a:effectRef>
-          <a:fontRef idx="minor">
-            <a:schemeClr val="lt1"/>
-          </a:fontRef>
-        </p:style>
-        <p:txBody>
-          <a:bodyPr rtlCol="0" anchor="ctr"/>
-          <a:lstStyle/>
-          <a:p>
-            <a:pPr algn="ctr"/>
-          </a:p>
-        </p:txBody>
-      </p:sp>
-      <p:sp>
-        <p:nvSpPr>
-          <p:cNvPr id="5" name="Rectangle 4"/>
+          <p:cNvPr id="6" name="Rectangle 5"/>
           <p:cNvSpPr/>
           <p:nvPr/>
         </p:nvSpPr>
@@ -9848,7 +9891,7 @@
       </p:sp>
       <p:sp>
         <p:nvSpPr>
-          <p:cNvPr id="6" name="Rectangle 5"/>
+          <p:cNvPr id="7" name="Rectangle 6"/>
           <p:cNvSpPr/>
           <p:nvPr/>
         </p:nvSpPr>
@@ -9891,7 +9934,7 @@
       </p:sp>
       <p:sp>
         <p:nvSpPr>
-          <p:cNvPr id="7" name="Rectangle 6"/>
+          <p:cNvPr id="8" name="Rectangle 7"/>
           <p:cNvSpPr/>
           <p:nvPr/>
         </p:nvSpPr>
@@ -9934,7 +9977,7 @@
       </p:sp>
       <p:sp>
         <p:nvSpPr>
-          <p:cNvPr id="8" name="Rectangle 7"/>
+          <p:cNvPr id="9" name="Rectangle 8"/>
           <p:cNvSpPr/>
           <p:nvPr/>
         </p:nvSpPr>
@@ -9977,7 +10020,7 @@
       </p:sp>
       <p:sp>
         <p:nvSpPr>
-          <p:cNvPr id="9" name="Oval 8"/>
+          <p:cNvPr id="10" name="Oval 9"/>
           <p:cNvSpPr/>
           <p:nvPr/>
         </p:nvSpPr>
@@ -10020,7 +10063,7 @@
       </p:sp>
       <p:sp>
         <p:nvSpPr>
-          <p:cNvPr id="10" name="Oval 9"/>
+          <p:cNvPr id="11" name="Oval 10"/>
           <p:cNvSpPr/>
           <p:nvPr/>
         </p:nvSpPr>
@@ -10063,7 +10106,7 @@
       </p:sp>
       <p:sp>
         <p:nvSpPr>
-          <p:cNvPr id="11" name="Rectangle 10"/>
+          <p:cNvPr id="12" name="Rectangle 11"/>
           <p:cNvSpPr/>
           <p:nvPr/>
         </p:nvSpPr>
@@ -10106,7 +10149,7 @@
       </p:sp>
       <p:sp>
         <p:nvSpPr>
-          <p:cNvPr id="12" name="Rectangle 11"/>
+          <p:cNvPr id="13" name="Rectangle 12"/>
           <p:cNvSpPr/>
           <p:nvPr/>
         </p:nvSpPr>
@@ -10149,7 +10192,7 @@
       </p:sp>
       <p:sp>
         <p:nvSpPr>
-          <p:cNvPr id="13" name="Rectangle 12"/>
+          <p:cNvPr id="14" name="Rectangle 13"/>
           <p:cNvSpPr/>
           <p:nvPr/>
         </p:nvSpPr>
@@ -10192,7 +10235,7 @@
       </p:sp>
       <p:sp>
         <p:nvSpPr>
-          <p:cNvPr id="14" name="Rectangle 13"/>
+          <p:cNvPr id="15" name="Rectangle 14"/>
           <p:cNvSpPr/>
           <p:nvPr/>
         </p:nvSpPr>
@@ -10235,7 +10278,7 @@
       </p:sp>
       <p:sp>
         <p:nvSpPr>
-          <p:cNvPr id="15" name="Rectangle 14"/>
+          <p:cNvPr id="16" name="Rectangle 15"/>
           <p:cNvSpPr/>
           <p:nvPr/>
         </p:nvSpPr>
@@ -10278,7 +10321,7 @@
       </p:sp>
       <p:sp>
         <p:nvSpPr>
-          <p:cNvPr id="16" name="Rectangle 15"/>
+          <p:cNvPr id="17" name="Rectangle 16"/>
           <p:cNvSpPr/>
           <p:nvPr/>
         </p:nvSpPr>
@@ -10321,7 +10364,7 @@
       </p:sp>
       <p:sp>
         <p:nvSpPr>
-          <p:cNvPr id="17" name="Rectangle 16"/>
+          <p:cNvPr id="18" name="Rectangle 17"/>
           <p:cNvSpPr/>
           <p:nvPr/>
         </p:nvSpPr>
@@ -10364,7 +10407,7 @@
       </p:sp>
       <p:sp>
         <p:nvSpPr>
-          <p:cNvPr id="18" name="Arc 17"/>
+          <p:cNvPr id="19" name="Arc 18"/>
           <p:cNvSpPr/>
           <p:nvPr/>
         </p:nvSpPr>
@@ -10407,7 +10450,7 @@
       </p:sp>
       <p:sp>
         <p:nvSpPr>
-          <p:cNvPr id="19" name="Rectangle 18"/>
+          <p:cNvPr id="20" name="Rectangle 19"/>
           <p:cNvSpPr/>
           <p:nvPr/>
         </p:nvSpPr>
@@ -10450,7 +10493,7 @@
       </p:sp>
       <p:sp>
         <p:nvSpPr>
-          <p:cNvPr id="20" name="Rectangle 19"/>
+          <p:cNvPr id="21" name="Rectangle 20"/>
           <p:cNvSpPr/>
           <p:nvPr/>
         </p:nvSpPr>
@@ -10493,7 +10536,7 @@
       </p:sp>
       <p:sp>
         <p:nvSpPr>
-          <p:cNvPr id="21" name="Rectangle 20"/>
+          <p:cNvPr id="22" name="Rectangle 21"/>
           <p:cNvSpPr/>
           <p:nvPr/>
         </p:nvSpPr>
@@ -10536,7 +10579,7 @@
       </p:sp>
       <p:sp>
         <p:nvSpPr>
-          <p:cNvPr id="22" name="Rectangle 21"/>
+          <p:cNvPr id="23" name="Rectangle 22"/>
           <p:cNvSpPr/>
           <p:nvPr/>
         </p:nvSpPr>
@@ -10579,7 +10622,7 @@
       </p:sp>
       <p:sp>
         <p:nvSpPr>
-          <p:cNvPr id="23" name="TextBox 22"/>
+          <p:cNvPr id="24" name="TextBox 23"/>
           <p:cNvSpPr txBox="1"/>
           <p:nvPr/>
         </p:nvSpPr>
@@ -10613,7 +10656,7 @@
       </p:sp>
       <p:sp>
         <p:nvSpPr>
-          <p:cNvPr id="24" name="Rectangle 23"/>
+          <p:cNvPr id="25" name="Rectangle 24"/>
           <p:cNvSpPr/>
           <p:nvPr/>
         </p:nvSpPr>
@@ -10656,7 +10699,7 @@
       </p:sp>
       <p:sp>
         <p:nvSpPr>
-          <p:cNvPr id="25" name="Rounded Rectangle 24"/>
+          <p:cNvPr id="26" name="Rounded Rectangle 25"/>
           <p:cNvSpPr/>
           <p:nvPr/>
         </p:nvSpPr>
@@ -10701,7 +10744,7 @@
       </p:sp>
       <p:sp>
         <p:nvSpPr>
-          <p:cNvPr id="26" name="Rounded Rectangle 25"/>
+          <p:cNvPr id="27" name="Rounded Rectangle 26"/>
           <p:cNvSpPr/>
           <p:nvPr/>
         </p:nvSpPr>
@@ -10748,7 +10791,7 @@
       </p:sp>
       <p:sp>
         <p:nvSpPr>
-          <p:cNvPr id="27" name="Rectangle 26"/>
+          <p:cNvPr id="28" name="Rectangle 27"/>
           <p:cNvSpPr/>
           <p:nvPr/>
         </p:nvSpPr>
@@ -10791,7 +10834,7 @@
       </p:sp>
       <p:sp>
         <p:nvSpPr>
-          <p:cNvPr id="28" name="TextBox 27"/>
+          <p:cNvPr id="29" name="TextBox 28"/>
           <p:cNvSpPr txBox="1"/>
           <p:nvPr/>
         </p:nvSpPr>
@@ -10825,7 +10868,7 @@
       </p:sp>
       <p:sp>
         <p:nvSpPr>
-          <p:cNvPr id="29" name="TextBox 28"/>
+          <p:cNvPr id="30" name="TextBox 29"/>
           <p:cNvSpPr txBox="1"/>
           <p:nvPr/>
         </p:nvSpPr>
@@ -10859,7 +10902,7 @@
       </p:sp>
       <p:sp>
         <p:nvSpPr>
-          <p:cNvPr id="30" name="TextBox 29"/>
+          <p:cNvPr id="31" name="TextBox 30"/>
           <p:cNvSpPr txBox="1"/>
           <p:nvPr/>
         </p:nvSpPr>
@@ -10893,7 +10936,7 @@
       </p:sp>
       <p:sp>
         <p:nvSpPr>
-          <p:cNvPr id="31" name="TextBox 30"/>
+          <p:cNvPr id="32" name="TextBox 31"/>
           <p:cNvSpPr txBox="1"/>
           <p:nvPr/>
         </p:nvSpPr>
@@ -10927,7 +10970,7 @@
       </p:sp>
       <p:sp>
         <p:nvSpPr>
-          <p:cNvPr id="32" name="Rectangle 31"/>
+          <p:cNvPr id="33" name="Rectangle 32"/>
           <p:cNvSpPr/>
           <p:nvPr/>
         </p:nvSpPr>
@@ -10970,7 +11013,7 @@
       </p:sp>
       <p:sp>
         <p:nvSpPr>
-          <p:cNvPr id="33" name="TextBox 32"/>
+          <p:cNvPr id="34" name="TextBox 33"/>
           <p:cNvSpPr txBox="1"/>
           <p:nvPr/>
         </p:nvSpPr>
@@ -11004,7 +11047,7 @@
       </p:sp>
       <p:sp>
         <p:nvSpPr>
-          <p:cNvPr id="34" name="TextBox 33"/>
+          <p:cNvPr id="35" name="TextBox 34"/>
           <p:cNvSpPr txBox="1"/>
           <p:nvPr/>
         </p:nvSpPr>
@@ -11038,7 +11081,7 @@
       </p:sp>
       <p:sp>
         <p:nvSpPr>
-          <p:cNvPr id="35" name="Rectangle 34"/>
+          <p:cNvPr id="36" name="Rectangle 35"/>
           <p:cNvSpPr/>
           <p:nvPr/>
         </p:nvSpPr>
@@ -11081,7 +11124,7 @@
       </p:sp>
       <p:sp>
         <p:nvSpPr>
-          <p:cNvPr id="36" name="TextBox 35"/>
+          <p:cNvPr id="37" name="TextBox 36"/>
           <p:cNvSpPr txBox="1"/>
           <p:nvPr/>
         </p:nvSpPr>
@@ -11115,7 +11158,7 @@
       </p:sp>
       <p:sp>
         <p:nvSpPr>
-          <p:cNvPr id="37" name="TextBox 36"/>
+          <p:cNvPr id="38" name="TextBox 37"/>
           <p:cNvSpPr txBox="1"/>
           <p:nvPr/>
         </p:nvSpPr>
@@ -11149,7 +11192,7 @@
       </p:sp>
       <p:sp>
         <p:nvSpPr>
-          <p:cNvPr id="38" name="Rectangle 37"/>
+          <p:cNvPr id="39" name="Rectangle 38"/>
           <p:cNvSpPr/>
           <p:nvPr/>
         </p:nvSpPr>
@@ -11192,7 +11235,7 @@
       </p:sp>
       <p:sp>
         <p:nvSpPr>
-          <p:cNvPr id="39" name="TextBox 38"/>
+          <p:cNvPr id="40" name="TextBox 39"/>
           <p:cNvSpPr txBox="1"/>
           <p:nvPr/>
         </p:nvSpPr>
@@ -11226,7 +11269,7 @@
       </p:sp>
       <p:sp>
         <p:nvSpPr>
-          <p:cNvPr id="40" name="TextBox 39"/>
+          <p:cNvPr id="41" name="TextBox 40"/>
           <p:cNvSpPr txBox="1"/>
           <p:nvPr/>
         </p:nvSpPr>
@@ -11260,7 +11303,7 @@
       </p:sp>
       <p:sp>
         <p:nvSpPr>
-          <p:cNvPr id="41" name="Rectangle 40"/>
+          <p:cNvPr id="42" name="Rectangle 41"/>
           <p:cNvSpPr/>
           <p:nvPr/>
         </p:nvSpPr>
@@ -11303,7 +11346,7 @@
       </p:sp>
       <p:sp>
         <p:nvSpPr>
-          <p:cNvPr id="42" name="TextBox 41"/>
+          <p:cNvPr id="43" name="TextBox 42"/>
           <p:cNvSpPr txBox="1"/>
           <p:nvPr/>
         </p:nvSpPr>
@@ -11337,7 +11380,7 @@
       </p:sp>
       <p:sp>
         <p:nvSpPr>
-          <p:cNvPr id="43" name="TextBox 42"/>
+          <p:cNvPr id="44" name="TextBox 43"/>
           <p:cNvSpPr txBox="1"/>
           <p:nvPr/>
         </p:nvSpPr>
@@ -11371,7 +11414,7 @@
       </p:sp>
       <p:sp>
         <p:nvSpPr>
-          <p:cNvPr id="44" name="Rounded Rectangle 43"/>
+          <p:cNvPr id="45" name="Rounded Rectangle 44"/>
           <p:cNvSpPr/>
           <p:nvPr/>
         </p:nvSpPr>
@@ -11416,7 +11459,7 @@
       </p:sp>
       <p:sp>
         <p:nvSpPr>
-          <p:cNvPr id="45" name="Rounded Rectangle 44"/>
+          <p:cNvPr id="46" name="Rounded Rectangle 45"/>
           <p:cNvSpPr/>
           <p:nvPr/>
         </p:nvSpPr>
@@ -11472,7 +11515,7 @@
       </p:sp>
       <p:sp>
         <p:nvSpPr>
-          <p:cNvPr id="46" name="Rounded Rectangle 45"/>
+          <p:cNvPr id="47" name="Rounded Rectangle 46"/>
           <p:cNvSpPr/>
           <p:nvPr/>
         </p:nvSpPr>
@@ -11517,7 +11560,7 @@
       </p:sp>
       <p:sp>
         <p:nvSpPr>
-          <p:cNvPr id="47" name="Rectangle 46"/>
+          <p:cNvPr id="48" name="Rectangle 47"/>
           <p:cNvSpPr/>
           <p:nvPr/>
         </p:nvSpPr>
@@ -11560,7 +11603,7 @@
       </p:sp>
       <p:sp>
         <p:nvSpPr>
-          <p:cNvPr id="48" name="Rectangle 47"/>
+          <p:cNvPr id="49" name="Rectangle 48"/>
           <p:cNvSpPr/>
           <p:nvPr/>
         </p:nvSpPr>
@@ -11603,7 +11646,7 @@
       </p:sp>
       <p:sp>
         <p:nvSpPr>
-          <p:cNvPr id="49" name="Rectangle 48"/>
+          <p:cNvPr id="50" name="Rectangle 49"/>
           <p:cNvSpPr/>
           <p:nvPr/>
         </p:nvSpPr>
@@ -11646,7 +11689,7 @@
       </p:sp>
       <p:sp>
         <p:nvSpPr>
-          <p:cNvPr id="50" name="Rectangle 49"/>
+          <p:cNvPr id="51" name="Rectangle 50"/>
           <p:cNvSpPr/>
           <p:nvPr/>
         </p:nvSpPr>
@@ -11689,7 +11732,7 @@
       </p:sp>
       <p:sp>
         <p:nvSpPr>
-          <p:cNvPr id="51" name="Rectangle 50"/>
+          <p:cNvPr id="52" name="Rectangle 51"/>
           <p:cNvSpPr/>
           <p:nvPr/>
         </p:nvSpPr>
@@ -11732,7 +11775,7 @@
       </p:sp>
       <p:sp>
         <p:nvSpPr>
-          <p:cNvPr id="52" name="Rectangle 51"/>
+          <p:cNvPr id="53" name="Rectangle 52"/>
           <p:cNvSpPr/>
           <p:nvPr/>
         </p:nvSpPr>
@@ -11775,7 +11818,7 @@
       </p:sp>
       <p:sp>
         <p:nvSpPr>
-          <p:cNvPr id="53" name="Rectangle 52"/>
+          <p:cNvPr id="54" name="Rectangle 53"/>
           <p:cNvSpPr/>
           <p:nvPr/>
         </p:nvSpPr>
@@ -11818,7 +11861,7 @@
       </p:sp>
       <p:sp>
         <p:nvSpPr>
-          <p:cNvPr id="54" name="TextBox 53"/>
+          <p:cNvPr id="55" name="TextBox 54"/>
           <p:cNvSpPr txBox="1"/>
           <p:nvPr/>
         </p:nvSpPr>
@@ -11852,7 +11895,7 @@
       </p:sp>
       <p:sp>
         <p:nvSpPr>
-          <p:cNvPr id="55" name="Rectangle 54"/>
+          <p:cNvPr id="56" name="Rectangle 55"/>
           <p:cNvSpPr/>
           <p:nvPr/>
         </p:nvSpPr>
@@ -11895,7 +11938,7 @@
       </p:sp>
       <p:sp>
         <p:nvSpPr>
-          <p:cNvPr id="56" name="Arc 55"/>
+          <p:cNvPr id="57" name="Arc 56"/>
           <p:cNvSpPr/>
           <p:nvPr/>
         </p:nvSpPr>
@@ -11938,7 +11981,7 @@
       </p:sp>
       <p:pic>
         <p:nvPicPr>
-          <p:cNvPr id="57" name="Picture 56" descr="go.png"/>
+          <p:cNvPr id="58" name="Picture 57" descr="go.png"/>
           <p:cNvPicPr>
             <a:picLocks noChangeAspect="1"/>
           </p:cNvPicPr>
@@ -11962,7 +12005,7 @@
       </p:pic>
       <p:sp>
         <p:nvSpPr>
-          <p:cNvPr id="58" name="Rectangle 57"/>
+          <p:cNvPr id="59" name="Rectangle 58"/>
           <p:cNvSpPr/>
           <p:nvPr/>
         </p:nvSpPr>
@@ -12005,7 +12048,7 @@
       </p:sp>
       <p:sp>
         <p:nvSpPr>
-          <p:cNvPr id="59" name="TextBox 58"/>
+          <p:cNvPr id="60" name="TextBox 59"/>
           <p:cNvSpPr txBox="1"/>
           <p:nvPr/>
         </p:nvSpPr>
@@ -12039,7 +12082,7 @@
       </p:sp>
       <p:sp>
         <p:nvSpPr>
-          <p:cNvPr id="60" name="TextBox 59"/>
+          <p:cNvPr id="61" name="TextBox 60"/>
           <p:cNvSpPr txBox="1"/>
           <p:nvPr/>
         </p:nvSpPr>
@@ -12100,7 +12143,7 @@
       <p:grpSpPr/>
       <p:pic>
         <p:nvPicPr>
-          <p:cNvPr id="2" name="Picture 1" descr="tech-bg-5.jpg"/>
+          <p:cNvPr id="2" name="Picture 1" descr="scene-01.jpg"/>
           <p:cNvPicPr>
             <a:picLocks noChangeAspect="1"/>
           </p:cNvPicPr>
@@ -12114,8 +12157,8 @@
         </p:blipFill>
         <p:spPr>
           <a:xfrm>
-            <a:off x="0" y="0"/>
-            <a:ext cx="12191695" cy="6858000"/>
+            <a:off x="7818120" y="0"/>
+            <a:ext cx="4370832" cy="6858000"/>
           </a:xfrm>
           <a:prstGeom prst="rect">
             <a:avLst/>
@@ -12130,8 +12173,8 @@
         </p:nvSpPr>
         <p:spPr>
           <a:xfrm>
-            <a:off x="0" y="0"/>
-            <a:ext cx="12191695" cy="6858000"/>
+            <a:off x="7699248" y="0"/>
+            <a:ext cx="4526280" cy="6858000"/>
           </a:xfrm>
           <a:prstGeom prst="rect">
             <a:avLst/>
@@ -14122,7 +14165,7 @@
       <p:grpSpPr/>
       <p:pic>
         <p:nvPicPr>
-          <p:cNvPr id="2" name="Picture 1" descr="tech-bg-6.jpg"/>
+          <p:cNvPr id="2" name="Picture 1" descr="scene-02.jpg"/>
           <p:cNvPicPr>
             <a:picLocks noChangeAspect="1"/>
           </p:cNvPicPr>
@@ -16691,7 +16734,7 @@
       <p:grpSpPr/>
       <p:pic>
         <p:nvPicPr>
-          <p:cNvPr id="2" name="Picture 1" descr="tech-bg-7.jpg"/>
+          <p:cNvPr id="2" name="Picture 1" descr="scene-03.jpg"/>
           <p:cNvPicPr>
             <a:picLocks noChangeAspect="1"/>
           </p:cNvPicPr>
@@ -16705,28 +16748,114 @@
         </p:blipFill>
         <p:spPr>
           <a:xfrm>
+            <a:off x="4754880" y="0"/>
+            <a:ext cx="7452360" cy="6858000"/>
+          </a:xfrm>
+          <a:prstGeom prst="rect">
+            <a:avLst/>
+          </a:prstGeom>
+        </p:spPr>
+      </p:pic>
+      <p:sp>
+        <p:nvSpPr>
+          <p:cNvPr id="3" name="Chevron 2"/>
+          <p:cNvSpPr/>
+          <p:nvPr/>
+        </p:nvSpPr>
+        <p:spPr>
+          <a:xfrm>
+            <a:off x="4434840" y="45720"/>
+            <a:ext cx="2423160" cy="6720840"/>
+          </a:xfrm>
+          <a:prstGeom prst="chevron">
+            <a:avLst/>
+          </a:prstGeom>
+          <a:solidFill>
+            <a:srgbClr val="E6EEFA"/>
+          </a:solidFill>
+          <a:ln>
+            <a:noFill/>
+          </a:ln>
+        </p:spPr>
+        <p:style>
+          <a:lnRef idx="1">
+            <a:schemeClr val="accent1"/>
+          </a:lnRef>
+          <a:fillRef idx="3">
+            <a:schemeClr val="accent1"/>
+          </a:fillRef>
+          <a:effectRef idx="2">
+            <a:schemeClr val="accent1"/>
+          </a:effectRef>
+          <a:fontRef idx="minor">
+            <a:schemeClr val="lt1"/>
+          </a:fontRef>
+        </p:style>
+        <p:txBody>
+          <a:bodyPr rtlCol="0" anchor="ctr"/>
+          <a:lstStyle/>
+          <a:p>
+            <a:pPr algn="ctr"/>
+          </a:p>
+        </p:txBody>
+      </p:sp>
+      <p:sp>
+        <p:nvSpPr>
+          <p:cNvPr id="4" name="Rectangle 3"/>
+          <p:cNvSpPr/>
+          <p:nvPr/>
+        </p:nvSpPr>
+        <p:spPr>
+          <a:xfrm>
+            <a:off x="4663440" y="0"/>
+            <a:ext cx="7543800" cy="6858000"/>
+          </a:xfrm>
+          <a:prstGeom prst="rect">
+            <a:avLst/>
+          </a:prstGeom>
+          <a:solidFill>
+            <a:srgbClr val="FFFFFF"/>
+          </a:solidFill>
+          <a:ln>
+            <a:noFill/>
+          </a:ln>
+        </p:spPr>
+        <p:style>
+          <a:lnRef idx="1">
+            <a:schemeClr val="accent1"/>
+          </a:lnRef>
+          <a:fillRef idx="3">
+            <a:schemeClr val="accent1"/>
+          </a:fillRef>
+          <a:effectRef idx="2">
+            <a:schemeClr val="accent1"/>
+          </a:effectRef>
+          <a:fontRef idx="minor">
+            <a:schemeClr val="lt1"/>
+          </a:fontRef>
+        </p:style>
+        <p:txBody>
+          <a:bodyPr rtlCol="0" anchor="ctr"/>
+          <a:lstStyle/>
+          <a:p>
+            <a:pPr algn="ctr"/>
+          </a:p>
+        </p:txBody>
+      </p:sp>
+      <p:sp>
+        <p:nvSpPr>
+          <p:cNvPr id="5" name="Rectangle 4"/>
+          <p:cNvSpPr/>
+          <p:nvPr/>
+        </p:nvSpPr>
+        <p:spPr>
+          <a:xfrm>
             <a:off x="0" y="0"/>
             <a:ext cx="12191695" cy="6858000"/>
           </a:xfrm>
           <a:prstGeom prst="rect">
             <a:avLst/>
           </a:prstGeom>
-        </p:spPr>
-      </p:pic>
-      <p:sp>
-        <p:nvSpPr>
-          <p:cNvPr id="3" name="Rectangle 2"/>
-          <p:cNvSpPr/>
-          <p:nvPr/>
-        </p:nvSpPr>
-        <p:spPr>
-          <a:xfrm>
-            <a:off x="0" y="0"/>
-            <a:ext cx="12191695" cy="6858000"/>
-          </a:xfrm>
-          <a:prstGeom prst="rect">
-            <a:avLst/>
-          </a:prstGeom>
           <a:solidFill>
             <a:srgbClr val="FFFFFF"/>
           </a:solidFill>
@@ -16758,50 +16887,7 @@
       </p:sp>
       <p:sp>
         <p:nvSpPr>
-          <p:cNvPr id="4" name="Rectangle 3"/>
-          <p:cNvSpPr/>
-          <p:nvPr/>
-        </p:nvSpPr>
-        <p:spPr>
-          <a:xfrm>
-            <a:off x="0" y="0"/>
-            <a:ext cx="12191695" cy="6858000"/>
-          </a:xfrm>
-          <a:prstGeom prst="rect">
-            <a:avLst/>
-          </a:prstGeom>
-          <a:solidFill>
-            <a:srgbClr val="FFFFFF"/>
-          </a:solidFill>
-          <a:ln>
-            <a:noFill/>
-          </a:ln>
-        </p:spPr>
-        <p:style>
-          <a:lnRef idx="1">
-            <a:schemeClr val="accent1"/>
-          </a:lnRef>
-          <a:fillRef idx="3">
-            <a:schemeClr val="accent1"/>
-          </a:fillRef>
-          <a:effectRef idx="2">
-            <a:schemeClr val="accent1"/>
-          </a:effectRef>
-          <a:fontRef idx="minor">
-            <a:schemeClr val="lt1"/>
-          </a:fontRef>
-        </p:style>
-        <p:txBody>
-          <a:bodyPr rtlCol="0" anchor="ctr"/>
-          <a:lstStyle/>
-          <a:p>
-            <a:pPr algn="ctr"/>
-          </a:p>
-        </p:txBody>
-      </p:sp>
-      <p:sp>
-        <p:nvSpPr>
-          <p:cNvPr id="5" name="Rectangle 4"/>
+          <p:cNvPr id="6" name="Rectangle 5"/>
           <p:cNvSpPr/>
           <p:nvPr/>
         </p:nvSpPr>
@@ -16844,7 +16930,7 @@
       </p:sp>
       <p:sp>
         <p:nvSpPr>
-          <p:cNvPr id="6" name="Rectangle 5"/>
+          <p:cNvPr id="7" name="Rectangle 6"/>
           <p:cNvSpPr/>
           <p:nvPr/>
         </p:nvSpPr>
@@ -16887,7 +16973,7 @@
       </p:sp>
       <p:sp>
         <p:nvSpPr>
-          <p:cNvPr id="7" name="Rectangle 6"/>
+          <p:cNvPr id="8" name="Rectangle 7"/>
           <p:cNvSpPr/>
           <p:nvPr/>
         </p:nvSpPr>
@@ -16930,7 +17016,7 @@
       </p:sp>
       <p:sp>
         <p:nvSpPr>
-          <p:cNvPr id="8" name="Rectangle 7"/>
+          <p:cNvPr id="9" name="Rectangle 8"/>
           <p:cNvSpPr/>
           <p:nvPr/>
         </p:nvSpPr>
@@ -16973,7 +17059,7 @@
       </p:sp>
       <p:sp>
         <p:nvSpPr>
-          <p:cNvPr id="9" name="Rectangle 8"/>
+          <p:cNvPr id="10" name="Rectangle 9"/>
           <p:cNvSpPr/>
           <p:nvPr/>
         </p:nvSpPr>
@@ -17016,7 +17102,7 @@
       </p:sp>
       <p:sp>
         <p:nvSpPr>
-          <p:cNvPr id="10" name="Rectangle 9"/>
+          <p:cNvPr id="11" name="Rectangle 10"/>
           <p:cNvSpPr/>
           <p:nvPr/>
         </p:nvSpPr>
@@ -17059,7 +17145,7 @@
       </p:sp>
       <p:sp>
         <p:nvSpPr>
-          <p:cNvPr id="11" name="Oval 10"/>
+          <p:cNvPr id="12" name="Oval 11"/>
           <p:cNvSpPr/>
           <p:nvPr/>
         </p:nvSpPr>
@@ -17102,7 +17188,7 @@
       </p:sp>
       <p:sp>
         <p:nvSpPr>
-          <p:cNvPr id="12" name="Oval 11"/>
+          <p:cNvPr id="13" name="Oval 12"/>
           <p:cNvSpPr/>
           <p:nvPr/>
         </p:nvSpPr>
@@ -17145,7 +17231,7 @@
       </p:sp>
       <p:sp>
         <p:nvSpPr>
-          <p:cNvPr id="13" name="Oval 12"/>
+          <p:cNvPr id="14" name="Oval 13"/>
           <p:cNvSpPr/>
           <p:nvPr/>
         </p:nvSpPr>
@@ -17188,7 +17274,7 @@
       </p:sp>
       <p:sp>
         <p:nvSpPr>
-          <p:cNvPr id="14" name="Oval 13"/>
+          <p:cNvPr id="15" name="Oval 14"/>
           <p:cNvSpPr/>
           <p:nvPr/>
         </p:nvSpPr>
@@ -17231,7 +17317,7 @@
       </p:sp>
       <p:sp>
         <p:nvSpPr>
-          <p:cNvPr id="15" name="Rectangle 14"/>
+          <p:cNvPr id="16" name="Rectangle 15"/>
           <p:cNvSpPr/>
           <p:nvPr/>
         </p:nvSpPr>
@@ -17274,7 +17360,7 @@
       </p:sp>
       <p:sp>
         <p:nvSpPr>
-          <p:cNvPr id="16" name="Rectangle 15"/>
+          <p:cNvPr id="17" name="Rectangle 16"/>
           <p:cNvSpPr/>
           <p:nvPr/>
         </p:nvSpPr>
@@ -17317,7 +17403,7 @@
       </p:sp>
       <p:sp>
         <p:nvSpPr>
-          <p:cNvPr id="17" name="Rectangle 16"/>
+          <p:cNvPr id="18" name="Rectangle 17"/>
           <p:cNvSpPr/>
           <p:nvPr/>
         </p:nvSpPr>
@@ -17360,7 +17446,7 @@
       </p:sp>
       <p:sp>
         <p:nvSpPr>
-          <p:cNvPr id="18" name="Rectangle 17"/>
+          <p:cNvPr id="19" name="Rectangle 18"/>
           <p:cNvSpPr/>
           <p:nvPr/>
         </p:nvSpPr>
@@ -17403,7 +17489,7 @@
       </p:sp>
       <p:sp>
         <p:nvSpPr>
-          <p:cNvPr id="19" name="Rectangle 18"/>
+          <p:cNvPr id="20" name="Rectangle 19"/>
           <p:cNvSpPr/>
           <p:nvPr/>
         </p:nvSpPr>
@@ -17446,7 +17532,7 @@
       </p:sp>
       <p:sp>
         <p:nvSpPr>
-          <p:cNvPr id="20" name="Rectangle 19"/>
+          <p:cNvPr id="21" name="Rectangle 20"/>
           <p:cNvSpPr/>
           <p:nvPr/>
         </p:nvSpPr>
@@ -17489,7 +17575,7 @@
       </p:sp>
       <p:sp>
         <p:nvSpPr>
-          <p:cNvPr id="21" name="Rectangle 20"/>
+          <p:cNvPr id="22" name="Rectangle 21"/>
           <p:cNvSpPr/>
           <p:nvPr/>
         </p:nvSpPr>
@@ -17532,7 +17618,7 @@
       </p:sp>
       <p:sp>
         <p:nvSpPr>
-          <p:cNvPr id="22" name="Arc 21"/>
+          <p:cNvPr id="23" name="Arc 22"/>
           <p:cNvSpPr/>
           <p:nvPr/>
         </p:nvSpPr>
@@ -17575,7 +17661,7 @@
       </p:sp>
       <p:sp>
         <p:nvSpPr>
-          <p:cNvPr id="23" name="Rectangle 22"/>
+          <p:cNvPr id="24" name="Rectangle 23"/>
           <p:cNvSpPr/>
           <p:nvPr/>
         </p:nvSpPr>
@@ -17618,7 +17704,7 @@
       </p:sp>
       <p:sp>
         <p:nvSpPr>
-          <p:cNvPr id="24" name="Rectangle 23"/>
+          <p:cNvPr id="25" name="Rectangle 24"/>
           <p:cNvSpPr/>
           <p:nvPr/>
         </p:nvSpPr>
@@ -17661,7 +17747,7 @@
       </p:sp>
       <p:sp>
         <p:nvSpPr>
-          <p:cNvPr id="25" name="Rectangle 24"/>
+          <p:cNvPr id="26" name="Rectangle 25"/>
           <p:cNvSpPr/>
           <p:nvPr/>
         </p:nvSpPr>
@@ -17704,7 +17790,7 @@
       </p:sp>
       <p:sp>
         <p:nvSpPr>
-          <p:cNvPr id="26" name="Rectangle 25"/>
+          <p:cNvPr id="27" name="Rectangle 26"/>
           <p:cNvSpPr/>
           <p:nvPr/>
         </p:nvSpPr>
@@ -17747,7 +17833,7 @@
       </p:sp>
       <p:sp>
         <p:nvSpPr>
-          <p:cNvPr id="27" name="Rounded Rectangle 26"/>
+          <p:cNvPr id="28" name="Rounded Rectangle 27"/>
           <p:cNvSpPr/>
           <p:nvPr/>
         </p:nvSpPr>
@@ -17792,7 +17878,7 @@
       </p:sp>
       <p:sp>
         <p:nvSpPr>
-          <p:cNvPr id="28" name="Rounded Rectangle 27"/>
+          <p:cNvPr id="29" name="Rounded Rectangle 28"/>
           <p:cNvSpPr/>
           <p:nvPr/>
         </p:nvSpPr>
@@ -17839,7 +17925,7 @@
       </p:sp>
       <p:sp>
         <p:nvSpPr>
-          <p:cNvPr id="29" name="Rectangle 28"/>
+          <p:cNvPr id="30" name="Rectangle 29"/>
           <p:cNvSpPr/>
           <p:nvPr/>
         </p:nvSpPr>
@@ -17882,7 +17968,7 @@
       </p:sp>
       <p:sp>
         <p:nvSpPr>
-          <p:cNvPr id="30" name="TextBox 29"/>
+          <p:cNvPr id="31" name="TextBox 30"/>
           <p:cNvSpPr txBox="1"/>
           <p:nvPr/>
         </p:nvSpPr>
@@ -17916,7 +18002,7 @@
       </p:sp>
       <p:sp>
         <p:nvSpPr>
-          <p:cNvPr id="31" name="TextBox 30"/>
+          <p:cNvPr id="32" name="TextBox 31"/>
           <p:cNvSpPr txBox="1"/>
           <p:nvPr/>
         </p:nvSpPr>
@@ -17950,7 +18036,7 @@
       </p:sp>
       <p:sp>
         <p:nvSpPr>
-          <p:cNvPr id="32" name="TextBox 31"/>
+          <p:cNvPr id="33" name="TextBox 32"/>
           <p:cNvSpPr txBox="1"/>
           <p:nvPr/>
         </p:nvSpPr>
@@ -17984,7 +18070,7 @@
       </p:sp>
       <p:sp>
         <p:nvSpPr>
-          <p:cNvPr id="33" name="TextBox 32"/>
+          <p:cNvPr id="34" name="TextBox 33"/>
           <p:cNvSpPr txBox="1"/>
           <p:nvPr/>
         </p:nvSpPr>
@@ -18018,7 +18104,7 @@
       </p:sp>
       <p:sp>
         <p:nvSpPr>
-          <p:cNvPr id="34" name="Rectangle 33"/>
+          <p:cNvPr id="35" name="Rectangle 34"/>
           <p:cNvSpPr/>
           <p:nvPr/>
         </p:nvSpPr>
@@ -18061,7 +18147,7 @@
       </p:sp>
       <p:sp>
         <p:nvSpPr>
-          <p:cNvPr id="35" name="TextBox 34"/>
+          <p:cNvPr id="36" name="TextBox 35"/>
           <p:cNvSpPr txBox="1"/>
           <p:nvPr/>
         </p:nvSpPr>
@@ -18095,7 +18181,7 @@
       </p:sp>
       <p:sp>
         <p:nvSpPr>
-          <p:cNvPr id="36" name="TextBox 35"/>
+          <p:cNvPr id="37" name="TextBox 36"/>
           <p:cNvSpPr txBox="1"/>
           <p:nvPr/>
         </p:nvSpPr>
@@ -18129,7 +18215,7 @@
       </p:sp>
       <p:sp>
         <p:nvSpPr>
-          <p:cNvPr id="37" name="Rectangle 36"/>
+          <p:cNvPr id="38" name="Rectangle 37"/>
           <p:cNvSpPr/>
           <p:nvPr/>
         </p:nvSpPr>
@@ -18172,7 +18258,7 @@
       </p:sp>
       <p:sp>
         <p:nvSpPr>
-          <p:cNvPr id="38" name="TextBox 37"/>
+          <p:cNvPr id="39" name="TextBox 38"/>
           <p:cNvSpPr txBox="1"/>
           <p:nvPr/>
         </p:nvSpPr>
@@ -18206,7 +18292,7 @@
       </p:sp>
       <p:sp>
         <p:nvSpPr>
-          <p:cNvPr id="39" name="TextBox 38"/>
+          <p:cNvPr id="40" name="TextBox 39"/>
           <p:cNvSpPr txBox="1"/>
           <p:nvPr/>
         </p:nvSpPr>
@@ -18240,7 +18326,7 @@
       </p:sp>
       <p:sp>
         <p:nvSpPr>
-          <p:cNvPr id="40" name="Rectangle 39"/>
+          <p:cNvPr id="41" name="Rectangle 40"/>
           <p:cNvSpPr/>
           <p:nvPr/>
         </p:nvSpPr>
@@ -18283,7 +18369,7 @@
       </p:sp>
       <p:sp>
         <p:nvSpPr>
-          <p:cNvPr id="41" name="TextBox 40"/>
+          <p:cNvPr id="42" name="TextBox 41"/>
           <p:cNvSpPr txBox="1"/>
           <p:nvPr/>
         </p:nvSpPr>
@@ -18317,7 +18403,7 @@
       </p:sp>
       <p:sp>
         <p:nvSpPr>
-          <p:cNvPr id="42" name="TextBox 41"/>
+          <p:cNvPr id="43" name="TextBox 42"/>
           <p:cNvSpPr txBox="1"/>
           <p:nvPr/>
         </p:nvSpPr>
@@ -18351,7 +18437,7 @@
       </p:sp>
       <p:sp>
         <p:nvSpPr>
-          <p:cNvPr id="43" name="Rectangle 42"/>
+          <p:cNvPr id="44" name="Rectangle 43"/>
           <p:cNvSpPr/>
           <p:nvPr/>
         </p:nvSpPr>
@@ -18394,7 +18480,7 @@
       </p:sp>
       <p:sp>
         <p:nvSpPr>
-          <p:cNvPr id="44" name="TextBox 43"/>
+          <p:cNvPr id="45" name="TextBox 44"/>
           <p:cNvSpPr txBox="1"/>
           <p:nvPr/>
         </p:nvSpPr>
@@ -18428,7 +18514,7 @@
       </p:sp>
       <p:sp>
         <p:nvSpPr>
-          <p:cNvPr id="45" name="TextBox 44"/>
+          <p:cNvPr id="46" name="TextBox 45"/>
           <p:cNvSpPr txBox="1"/>
           <p:nvPr/>
         </p:nvSpPr>
@@ -18462,7 +18548,7 @@
       </p:sp>
       <p:sp>
         <p:nvSpPr>
-          <p:cNvPr id="46" name="Rectangle 45"/>
+          <p:cNvPr id="47" name="Rectangle 46"/>
           <p:cNvSpPr/>
           <p:nvPr/>
         </p:nvSpPr>
@@ -18505,7 +18591,7 @@
       </p:sp>
       <p:sp>
         <p:nvSpPr>
-          <p:cNvPr id="47" name="TextBox 46"/>
+          <p:cNvPr id="48" name="TextBox 47"/>
           <p:cNvSpPr txBox="1"/>
           <p:nvPr/>
         </p:nvSpPr>
@@ -18539,7 +18625,7 @@
       </p:sp>
       <p:sp>
         <p:nvSpPr>
-          <p:cNvPr id="48" name="TextBox 47"/>
+          <p:cNvPr id="49" name="TextBox 48"/>
           <p:cNvSpPr txBox="1"/>
           <p:nvPr/>
         </p:nvSpPr>
@@ -18573,7 +18659,7 @@
       </p:sp>
       <p:sp>
         <p:nvSpPr>
-          <p:cNvPr id="49" name="Rounded Rectangle 48"/>
+          <p:cNvPr id="50" name="Rounded Rectangle 49"/>
           <p:cNvSpPr/>
           <p:nvPr/>
         </p:nvSpPr>
@@ -18618,7 +18704,7 @@
       </p:sp>
       <p:sp>
         <p:nvSpPr>
-          <p:cNvPr id="50" name="Rounded Rectangle 49"/>
+          <p:cNvPr id="51" name="Rounded Rectangle 50"/>
           <p:cNvSpPr/>
           <p:nvPr/>
         </p:nvSpPr>
@@ -18674,7 +18760,7 @@
       </p:sp>
       <p:sp>
         <p:nvSpPr>
-          <p:cNvPr id="51" name="Rounded Rectangle 50"/>
+          <p:cNvPr id="52" name="Rounded Rectangle 51"/>
           <p:cNvSpPr/>
           <p:nvPr/>
         </p:nvSpPr>
@@ -18719,7 +18805,7 @@
       </p:sp>
       <p:sp>
         <p:nvSpPr>
-          <p:cNvPr id="52" name="Rectangle 51"/>
+          <p:cNvPr id="53" name="Rectangle 52"/>
           <p:cNvSpPr/>
           <p:nvPr/>
         </p:nvSpPr>
@@ -18762,7 +18848,7 @@
       </p:sp>
       <p:sp>
         <p:nvSpPr>
-          <p:cNvPr id="53" name="Rectangle 52"/>
+          <p:cNvPr id="54" name="Rectangle 53"/>
           <p:cNvSpPr/>
           <p:nvPr/>
         </p:nvSpPr>
@@ -18805,7 +18891,7 @@
       </p:sp>
       <p:sp>
         <p:nvSpPr>
-          <p:cNvPr id="54" name="Rectangle 53"/>
+          <p:cNvPr id="55" name="Rectangle 54"/>
           <p:cNvSpPr/>
           <p:nvPr/>
         </p:nvSpPr>
@@ -18848,7 +18934,7 @@
       </p:sp>
       <p:sp>
         <p:nvSpPr>
-          <p:cNvPr id="55" name="Rectangle 54"/>
+          <p:cNvPr id="56" name="Rectangle 55"/>
           <p:cNvSpPr/>
           <p:nvPr/>
         </p:nvSpPr>
@@ -18891,7 +18977,7 @@
       </p:sp>
       <p:sp>
         <p:nvSpPr>
-          <p:cNvPr id="56" name="Rectangle 55"/>
+          <p:cNvPr id="57" name="Rectangle 56"/>
           <p:cNvSpPr/>
           <p:nvPr/>
         </p:nvSpPr>
@@ -18934,7 +19020,7 @@
       </p:sp>
       <p:sp>
         <p:nvSpPr>
-          <p:cNvPr id="57" name="Rectangle 56"/>
+          <p:cNvPr id="58" name="Rectangle 57"/>
           <p:cNvSpPr/>
           <p:nvPr/>
         </p:nvSpPr>
@@ -18977,7 +19063,7 @@
       </p:sp>
       <p:sp>
         <p:nvSpPr>
-          <p:cNvPr id="58" name="Rectangle 57"/>
+          <p:cNvPr id="59" name="Rectangle 58"/>
           <p:cNvSpPr/>
           <p:nvPr/>
         </p:nvSpPr>
@@ -19020,7 +19106,7 @@
       </p:sp>
       <p:sp>
         <p:nvSpPr>
-          <p:cNvPr id="59" name="TextBox 58"/>
+          <p:cNvPr id="60" name="TextBox 59"/>
           <p:cNvSpPr txBox="1"/>
           <p:nvPr/>
         </p:nvSpPr>
@@ -19054,7 +19140,7 @@
       </p:sp>
       <p:sp>
         <p:nvSpPr>
-          <p:cNvPr id="60" name="Rectangle 59"/>
+          <p:cNvPr id="61" name="Rectangle 60"/>
           <p:cNvSpPr/>
           <p:nvPr/>
         </p:nvSpPr>
@@ -19097,7 +19183,7 @@
       </p:sp>
       <p:sp>
         <p:nvSpPr>
-          <p:cNvPr id="61" name="TextBox 60"/>
+          <p:cNvPr id="62" name="TextBox 61"/>
           <p:cNvSpPr txBox="1"/>
           <p:nvPr/>
         </p:nvSpPr>
@@ -19131,7 +19217,7 @@
       </p:sp>
       <p:sp>
         <p:nvSpPr>
-          <p:cNvPr id="62" name="Rectangle 61"/>
+          <p:cNvPr id="63" name="Rectangle 62"/>
           <p:cNvSpPr/>
           <p:nvPr/>
         </p:nvSpPr>
@@ -19174,7 +19260,7 @@
       </p:sp>
       <p:sp>
         <p:nvSpPr>
-          <p:cNvPr id="63" name="Arc 62"/>
+          <p:cNvPr id="64" name="Arc 63"/>
           <p:cNvSpPr/>
           <p:nvPr/>
         </p:nvSpPr>
@@ -19217,7 +19303,7 @@
       </p:sp>
       <p:sp>
         <p:nvSpPr>
-          <p:cNvPr id="64" name="Rectangle 63"/>
+          <p:cNvPr id="65" name="Rectangle 64"/>
           <p:cNvSpPr/>
           <p:nvPr/>
         </p:nvSpPr>
@@ -19260,7 +19346,7 @@
       </p:sp>
       <p:sp>
         <p:nvSpPr>
-          <p:cNvPr id="65" name="TextBox 64"/>
+          <p:cNvPr id="66" name="TextBox 65"/>
           <p:cNvSpPr txBox="1"/>
           <p:nvPr/>
         </p:nvSpPr>
@@ -19294,7 +19380,7 @@
       </p:sp>
       <p:sp>
         <p:nvSpPr>
-          <p:cNvPr id="66" name="TextBox 65"/>
+          <p:cNvPr id="67" name="TextBox 66"/>
           <p:cNvSpPr txBox="1"/>
           <p:nvPr/>
         </p:nvSpPr>
@@ -19355,7 +19441,7 @@
       <p:grpSpPr/>
       <p:pic>
         <p:nvPicPr>
-          <p:cNvPr id="2" name="Picture 1" descr="tech-bg-8.jpg"/>
+          <p:cNvPr id="2" name="Picture 1" descr="scene-04.jpg"/>
           <p:cNvPicPr>
             <a:picLocks noChangeAspect="1"/>
           </p:cNvPicPr>
@@ -19369,8 +19455,8 @@
         </p:blipFill>
         <p:spPr>
           <a:xfrm>
-            <a:off x="0" y="0"/>
-            <a:ext cx="12191695" cy="6858000"/>
+            <a:off x="7818120" y="0"/>
+            <a:ext cx="4370832" cy="6858000"/>
           </a:xfrm>
           <a:prstGeom prst="rect">
             <a:avLst/>
@@ -19385,8 +19471,8 @@
         </p:nvSpPr>
         <p:spPr>
           <a:xfrm>
-            <a:off x="0" y="0"/>
-            <a:ext cx="12191695" cy="6858000"/>
+            <a:off x="7699248" y="0"/>
+            <a:ext cx="4526280" cy="6858000"/>
           </a:xfrm>
           <a:prstGeom prst="rect">
             <a:avLst/>
@@ -21281,7 +21367,7 @@
       <p:grpSpPr/>
       <p:pic>
         <p:nvPicPr>
-          <p:cNvPr id="2" name="Picture 1" descr="tech-bg-1.jpg"/>
+          <p:cNvPr id="2" name="Picture 1" descr="scene-05.jpg"/>
           <p:cNvPicPr>
             <a:picLocks noChangeAspect="1"/>
           </p:cNvPicPr>
@@ -23850,7 +23936,7 @@
       <p:grpSpPr/>
       <p:pic>
         <p:nvPicPr>
-          <p:cNvPr id="2" name="Picture 1" descr="tech-bg-2.jpg"/>
+          <p:cNvPr id="2" name="Picture 1" descr="scene-06.jpg"/>
           <p:cNvPicPr>
             <a:picLocks noChangeAspect="1"/>
           </p:cNvPicPr>
@@ -23864,28 +23950,114 @@
         </p:blipFill>
         <p:spPr>
           <a:xfrm>
+            <a:off x="4754880" y="0"/>
+            <a:ext cx="7452360" cy="6858000"/>
+          </a:xfrm>
+          <a:prstGeom prst="rect">
+            <a:avLst/>
+          </a:prstGeom>
+        </p:spPr>
+      </p:pic>
+      <p:sp>
+        <p:nvSpPr>
+          <p:cNvPr id="3" name="Chevron 2"/>
+          <p:cNvSpPr/>
+          <p:nvPr/>
+        </p:nvSpPr>
+        <p:spPr>
+          <a:xfrm>
+            <a:off x="4434840" y="45720"/>
+            <a:ext cx="2423160" cy="6720840"/>
+          </a:xfrm>
+          <a:prstGeom prst="chevron">
+            <a:avLst/>
+          </a:prstGeom>
+          <a:solidFill>
+            <a:srgbClr val="E6EEFA"/>
+          </a:solidFill>
+          <a:ln>
+            <a:noFill/>
+          </a:ln>
+        </p:spPr>
+        <p:style>
+          <a:lnRef idx="1">
+            <a:schemeClr val="accent1"/>
+          </a:lnRef>
+          <a:fillRef idx="3">
+            <a:schemeClr val="accent1"/>
+          </a:fillRef>
+          <a:effectRef idx="2">
+            <a:schemeClr val="accent1"/>
+          </a:effectRef>
+          <a:fontRef idx="minor">
+            <a:schemeClr val="lt1"/>
+          </a:fontRef>
+        </p:style>
+        <p:txBody>
+          <a:bodyPr rtlCol="0" anchor="ctr"/>
+          <a:lstStyle/>
+          <a:p>
+            <a:pPr algn="ctr"/>
+          </a:p>
+        </p:txBody>
+      </p:sp>
+      <p:sp>
+        <p:nvSpPr>
+          <p:cNvPr id="4" name="Rectangle 3"/>
+          <p:cNvSpPr/>
+          <p:nvPr/>
+        </p:nvSpPr>
+        <p:spPr>
+          <a:xfrm>
+            <a:off x="4663440" y="0"/>
+            <a:ext cx="7543800" cy="6858000"/>
+          </a:xfrm>
+          <a:prstGeom prst="rect">
+            <a:avLst/>
+          </a:prstGeom>
+          <a:solidFill>
+            <a:srgbClr val="FFFFFF"/>
+          </a:solidFill>
+          <a:ln>
+            <a:noFill/>
+          </a:ln>
+        </p:spPr>
+        <p:style>
+          <a:lnRef idx="1">
+            <a:schemeClr val="accent1"/>
+          </a:lnRef>
+          <a:fillRef idx="3">
+            <a:schemeClr val="accent1"/>
+          </a:fillRef>
+          <a:effectRef idx="2">
+            <a:schemeClr val="accent1"/>
+          </a:effectRef>
+          <a:fontRef idx="minor">
+            <a:schemeClr val="lt1"/>
+          </a:fontRef>
+        </p:style>
+        <p:txBody>
+          <a:bodyPr rtlCol="0" anchor="ctr"/>
+          <a:lstStyle/>
+          <a:p>
+            <a:pPr algn="ctr"/>
+          </a:p>
+        </p:txBody>
+      </p:sp>
+      <p:sp>
+        <p:nvSpPr>
+          <p:cNvPr id="5" name="Rectangle 4"/>
+          <p:cNvSpPr/>
+          <p:nvPr/>
+        </p:nvSpPr>
+        <p:spPr>
+          <a:xfrm>
             <a:off x="0" y="0"/>
             <a:ext cx="12191695" cy="6858000"/>
           </a:xfrm>
           <a:prstGeom prst="rect">
             <a:avLst/>
           </a:prstGeom>
-        </p:spPr>
-      </p:pic>
-      <p:sp>
-        <p:nvSpPr>
-          <p:cNvPr id="3" name="Rectangle 2"/>
-          <p:cNvSpPr/>
-          <p:nvPr/>
-        </p:nvSpPr>
-        <p:spPr>
-          <a:xfrm>
-            <a:off x="0" y="0"/>
-            <a:ext cx="12191695" cy="6858000"/>
-          </a:xfrm>
-          <a:prstGeom prst="rect">
-            <a:avLst/>
-          </a:prstGeom>
           <a:solidFill>
             <a:srgbClr val="FFFFFF"/>
           </a:solidFill>
@@ -23917,50 +24089,7 @@
       </p:sp>
       <p:sp>
         <p:nvSpPr>
-          <p:cNvPr id="4" name="Rectangle 3"/>
-          <p:cNvSpPr/>
-          <p:nvPr/>
-        </p:nvSpPr>
-        <p:spPr>
-          <a:xfrm>
-            <a:off x="0" y="0"/>
-            <a:ext cx="12191695" cy="6858000"/>
-          </a:xfrm>
-          <a:prstGeom prst="rect">
-            <a:avLst/>
-          </a:prstGeom>
-          <a:solidFill>
-            <a:srgbClr val="FFFFFF"/>
-          </a:solidFill>
-          <a:ln>
-            <a:noFill/>
-          </a:ln>
-        </p:spPr>
-        <p:style>
-          <a:lnRef idx="1">
-            <a:schemeClr val="accent1"/>
-          </a:lnRef>
-          <a:fillRef idx="3">
-            <a:schemeClr val="accent1"/>
-          </a:fillRef>
-          <a:effectRef idx="2">
-            <a:schemeClr val="accent1"/>
-          </a:effectRef>
-          <a:fontRef idx="minor">
-            <a:schemeClr val="lt1"/>
-          </a:fontRef>
-        </p:style>
-        <p:txBody>
-          <a:bodyPr rtlCol="0" anchor="ctr"/>
-          <a:lstStyle/>
-          <a:p>
-            <a:pPr algn="ctr"/>
-          </a:p>
-        </p:txBody>
-      </p:sp>
-      <p:sp>
-        <p:nvSpPr>
-          <p:cNvPr id="5" name="Rectangle 4"/>
+          <p:cNvPr id="6" name="Rectangle 5"/>
           <p:cNvSpPr/>
           <p:nvPr/>
         </p:nvSpPr>
@@ -24003,7 +24132,7 @@
       </p:sp>
       <p:sp>
         <p:nvSpPr>
-          <p:cNvPr id="6" name="Rectangle 5"/>
+          <p:cNvPr id="7" name="Rectangle 6"/>
           <p:cNvSpPr/>
           <p:nvPr/>
         </p:nvSpPr>
@@ -24046,7 +24175,7 @@
       </p:sp>
       <p:sp>
         <p:nvSpPr>
-          <p:cNvPr id="7" name="Rectangle 6"/>
+          <p:cNvPr id="8" name="Rectangle 7"/>
           <p:cNvSpPr/>
           <p:nvPr/>
         </p:nvSpPr>
@@ -24089,7 +24218,7 @@
       </p:sp>
       <p:sp>
         <p:nvSpPr>
-          <p:cNvPr id="8" name="Rectangle 7"/>
+          <p:cNvPr id="9" name="Rectangle 8"/>
           <p:cNvSpPr/>
           <p:nvPr/>
         </p:nvSpPr>
@@ -24132,7 +24261,7 @@
       </p:sp>
       <p:sp>
         <p:nvSpPr>
-          <p:cNvPr id="9" name="Oval 8"/>
+          <p:cNvPr id="10" name="Oval 9"/>
           <p:cNvSpPr/>
           <p:nvPr/>
         </p:nvSpPr>
@@ -24175,7 +24304,7 @@
       </p:sp>
       <p:sp>
         <p:nvSpPr>
-          <p:cNvPr id="10" name="Oval 9"/>
+          <p:cNvPr id="11" name="Oval 10"/>
           <p:cNvSpPr/>
           <p:nvPr/>
         </p:nvSpPr>
@@ -24218,7 +24347,7 @@
       </p:sp>
       <p:sp>
         <p:nvSpPr>
-          <p:cNvPr id="11" name="Rectangle 10"/>
+          <p:cNvPr id="12" name="Rectangle 11"/>
           <p:cNvSpPr/>
           <p:nvPr/>
         </p:nvSpPr>
@@ -24261,7 +24390,7 @@
       </p:sp>
       <p:sp>
         <p:nvSpPr>
-          <p:cNvPr id="12" name="Rectangle 11"/>
+          <p:cNvPr id="13" name="Rectangle 12"/>
           <p:cNvSpPr/>
           <p:nvPr/>
         </p:nvSpPr>
@@ -24304,7 +24433,7 @@
       </p:sp>
       <p:sp>
         <p:nvSpPr>
-          <p:cNvPr id="13" name="Rectangle 12"/>
+          <p:cNvPr id="14" name="Rectangle 13"/>
           <p:cNvSpPr/>
           <p:nvPr/>
         </p:nvSpPr>
@@ -24347,7 +24476,7 @@
       </p:sp>
       <p:sp>
         <p:nvSpPr>
-          <p:cNvPr id="14" name="Rectangle 13"/>
+          <p:cNvPr id="15" name="Rectangle 14"/>
           <p:cNvSpPr/>
           <p:nvPr/>
         </p:nvSpPr>
@@ -24390,7 +24519,7 @@
       </p:sp>
       <p:sp>
         <p:nvSpPr>
-          <p:cNvPr id="15" name="Rectangle 14"/>
+          <p:cNvPr id="16" name="Rectangle 15"/>
           <p:cNvSpPr/>
           <p:nvPr/>
         </p:nvSpPr>
@@ -24433,7 +24562,7 @@
       </p:sp>
       <p:sp>
         <p:nvSpPr>
-          <p:cNvPr id="16" name="Rectangle 15"/>
+          <p:cNvPr id="17" name="Rectangle 16"/>
           <p:cNvSpPr/>
           <p:nvPr/>
         </p:nvSpPr>
@@ -24476,7 +24605,7 @@
       </p:sp>
       <p:sp>
         <p:nvSpPr>
-          <p:cNvPr id="17" name="Rectangle 16"/>
+          <p:cNvPr id="18" name="Rectangle 17"/>
           <p:cNvSpPr/>
           <p:nvPr/>
         </p:nvSpPr>
@@ -24519,7 +24648,7 @@
       </p:sp>
       <p:sp>
         <p:nvSpPr>
-          <p:cNvPr id="18" name="Arc 17"/>
+          <p:cNvPr id="19" name="Arc 18"/>
           <p:cNvSpPr/>
           <p:nvPr/>
         </p:nvSpPr>
@@ -24562,7 +24691,7 @@
       </p:sp>
       <p:sp>
         <p:nvSpPr>
-          <p:cNvPr id="19" name="Rectangle 18"/>
+          <p:cNvPr id="20" name="Rectangle 19"/>
           <p:cNvSpPr/>
           <p:nvPr/>
         </p:nvSpPr>
@@ -24605,7 +24734,7 @@
       </p:sp>
       <p:sp>
         <p:nvSpPr>
-          <p:cNvPr id="20" name="Rectangle 19"/>
+          <p:cNvPr id="21" name="Rectangle 20"/>
           <p:cNvSpPr/>
           <p:nvPr/>
         </p:nvSpPr>
@@ -24648,7 +24777,7 @@
       </p:sp>
       <p:sp>
         <p:nvSpPr>
-          <p:cNvPr id="21" name="Rectangle 20"/>
+          <p:cNvPr id="22" name="Rectangle 21"/>
           <p:cNvSpPr/>
           <p:nvPr/>
         </p:nvSpPr>
@@ -24691,7 +24820,7 @@
       </p:sp>
       <p:sp>
         <p:nvSpPr>
-          <p:cNvPr id="22" name="Rectangle 21"/>
+          <p:cNvPr id="23" name="Rectangle 22"/>
           <p:cNvSpPr/>
           <p:nvPr/>
         </p:nvSpPr>
@@ -24734,7 +24863,7 @@
       </p:sp>
       <p:sp>
         <p:nvSpPr>
-          <p:cNvPr id="23" name="TextBox 22"/>
+          <p:cNvPr id="24" name="TextBox 23"/>
           <p:cNvSpPr txBox="1"/>
           <p:nvPr/>
         </p:nvSpPr>
@@ -24768,7 +24897,7 @@
       </p:sp>
       <p:sp>
         <p:nvSpPr>
-          <p:cNvPr id="24" name="Rectangle 23"/>
+          <p:cNvPr id="25" name="Rectangle 24"/>
           <p:cNvSpPr/>
           <p:nvPr/>
         </p:nvSpPr>
@@ -24811,7 +24940,7 @@
       </p:sp>
       <p:sp>
         <p:nvSpPr>
-          <p:cNvPr id="25" name="Rounded Rectangle 24"/>
+          <p:cNvPr id="26" name="Rounded Rectangle 25"/>
           <p:cNvSpPr/>
           <p:nvPr/>
         </p:nvSpPr>
@@ -24856,7 +24985,7 @@
       </p:sp>
       <p:sp>
         <p:nvSpPr>
-          <p:cNvPr id="26" name="Rounded Rectangle 25"/>
+          <p:cNvPr id="27" name="Rounded Rectangle 26"/>
           <p:cNvSpPr/>
           <p:nvPr/>
         </p:nvSpPr>
@@ -24903,7 +25032,7 @@
       </p:sp>
       <p:sp>
         <p:nvSpPr>
-          <p:cNvPr id="27" name="Rounded Rectangle 26"/>
+          <p:cNvPr id="28" name="Rounded Rectangle 27"/>
           <p:cNvSpPr/>
           <p:nvPr/>
         </p:nvSpPr>
@@ -24948,7 +25077,7 @@
       </p:sp>
       <p:sp>
         <p:nvSpPr>
-          <p:cNvPr id="28" name="Rounded Rectangle 27"/>
+          <p:cNvPr id="29" name="Rounded Rectangle 28"/>
           <p:cNvSpPr/>
           <p:nvPr/>
         </p:nvSpPr>
@@ -24995,7 +25124,7 @@
       </p:sp>
       <p:sp>
         <p:nvSpPr>
-          <p:cNvPr id="29" name="Rounded Rectangle 28"/>
+          <p:cNvPr id="30" name="Rounded Rectangle 29"/>
           <p:cNvSpPr/>
           <p:nvPr/>
         </p:nvSpPr>
@@ -25040,7 +25169,7 @@
       </p:sp>
       <p:sp>
         <p:nvSpPr>
-          <p:cNvPr id="30" name="Rounded Rectangle 29"/>
+          <p:cNvPr id="31" name="Rounded Rectangle 30"/>
           <p:cNvSpPr/>
           <p:nvPr/>
         </p:nvSpPr>
@@ -25096,7 +25225,7 @@
       </p:sp>
       <p:sp>
         <p:nvSpPr>
-          <p:cNvPr id="31" name="Rounded Rectangle 30"/>
+          <p:cNvPr id="32" name="Rounded Rectangle 31"/>
           <p:cNvSpPr/>
           <p:nvPr/>
         </p:nvSpPr>
@@ -25141,7 +25270,7 @@
       </p:sp>
       <p:sp>
         <p:nvSpPr>
-          <p:cNvPr id="32" name="Rectangle 31"/>
+          <p:cNvPr id="33" name="Rectangle 32"/>
           <p:cNvSpPr/>
           <p:nvPr/>
         </p:nvSpPr>
@@ -25184,7 +25313,7 @@
       </p:sp>
       <p:sp>
         <p:nvSpPr>
-          <p:cNvPr id="33" name="Rectangle 32"/>
+          <p:cNvPr id="34" name="Rectangle 33"/>
           <p:cNvSpPr/>
           <p:nvPr/>
         </p:nvSpPr>
@@ -25227,7 +25356,7 @@
       </p:sp>
       <p:sp>
         <p:nvSpPr>
-          <p:cNvPr id="34" name="Rectangle 33"/>
+          <p:cNvPr id="35" name="Rectangle 34"/>
           <p:cNvSpPr/>
           <p:nvPr/>
         </p:nvSpPr>
@@ -25270,7 +25399,7 @@
       </p:sp>
       <p:sp>
         <p:nvSpPr>
-          <p:cNvPr id="35" name="Rectangle 34"/>
+          <p:cNvPr id="36" name="Rectangle 35"/>
           <p:cNvSpPr/>
           <p:nvPr/>
         </p:nvSpPr>
@@ -25313,7 +25442,7 @@
       </p:sp>
       <p:sp>
         <p:nvSpPr>
-          <p:cNvPr id="36" name="Rectangle 35"/>
+          <p:cNvPr id="37" name="Rectangle 36"/>
           <p:cNvSpPr/>
           <p:nvPr/>
         </p:nvSpPr>
@@ -25356,7 +25485,7 @@
       </p:sp>
       <p:sp>
         <p:nvSpPr>
-          <p:cNvPr id="37" name="Rectangle 36"/>
+          <p:cNvPr id="38" name="Rectangle 37"/>
           <p:cNvSpPr/>
           <p:nvPr/>
         </p:nvSpPr>
@@ -25399,7 +25528,7 @@
       </p:sp>
       <p:sp>
         <p:nvSpPr>
-          <p:cNvPr id="38" name="Rectangle 37"/>
+          <p:cNvPr id="39" name="Rectangle 38"/>
           <p:cNvSpPr/>
           <p:nvPr/>
         </p:nvSpPr>
@@ -25442,7 +25571,7 @@
       </p:sp>
       <p:sp>
         <p:nvSpPr>
-          <p:cNvPr id="39" name="TextBox 38"/>
+          <p:cNvPr id="40" name="TextBox 39"/>
           <p:cNvSpPr txBox="1"/>
           <p:nvPr/>
         </p:nvSpPr>
@@ -25476,7 +25605,7 @@
       </p:sp>
       <p:sp>
         <p:nvSpPr>
-          <p:cNvPr id="40" name="Rectangle 39"/>
+          <p:cNvPr id="41" name="Rectangle 40"/>
           <p:cNvSpPr/>
           <p:nvPr/>
         </p:nvSpPr>
@@ -25519,7 +25648,7 @@
       </p:sp>
       <p:sp>
         <p:nvSpPr>
-          <p:cNvPr id="41" name="Arc 40"/>
+          <p:cNvPr id="42" name="Arc 41"/>
           <p:cNvSpPr/>
           <p:nvPr/>
         </p:nvSpPr>
@@ -25562,7 +25691,7 @@
       </p:sp>
       <p:pic>
         <p:nvPicPr>
-          <p:cNvPr id="42" name="Picture 41" descr="github.png"/>
+          <p:cNvPr id="43" name="Picture 42" descr="github.png"/>
           <p:cNvPicPr>
             <a:picLocks noChangeAspect="1"/>
           </p:cNvPicPr>
@@ -25586,7 +25715,7 @@
       </p:pic>
       <p:sp>
         <p:nvSpPr>
-          <p:cNvPr id="43" name="TextBox 42"/>
+          <p:cNvPr id="44" name="TextBox 43"/>
           <p:cNvSpPr txBox="1"/>
           <p:nvPr/>
         </p:nvSpPr>
@@ -25666,7 +25795,7 @@
       </p:sp>
       <p:sp>
         <p:nvSpPr>
-          <p:cNvPr id="44" name="TextBox 43"/>
+          <p:cNvPr id="45" name="TextBox 44"/>
           <p:cNvSpPr txBox="1"/>
           <p:nvPr/>
         </p:nvSpPr>
@@ -25727,7 +25856,7 @@
       </p:sp>
       <p:sp>
         <p:nvSpPr>
-          <p:cNvPr id="45" name="Rectangle 44"/>
+          <p:cNvPr id="46" name="Rectangle 45"/>
           <p:cNvSpPr/>
           <p:nvPr/>
         </p:nvSpPr>
@@ -25770,7 +25899,7 @@
       </p:sp>
       <p:sp>
         <p:nvSpPr>
-          <p:cNvPr id="46" name="TextBox 45"/>
+          <p:cNvPr id="47" name="TextBox 46"/>
           <p:cNvSpPr txBox="1"/>
           <p:nvPr/>
         </p:nvSpPr>
@@ -25804,7 +25933,7 @@
       </p:sp>
       <p:sp>
         <p:nvSpPr>
-          <p:cNvPr id="47" name="TextBox 46"/>
+          <p:cNvPr id="48" name="TextBox 47"/>
           <p:cNvSpPr txBox="1"/>
           <p:nvPr/>
         </p:nvSpPr>
@@ -25865,7 +25994,7 @@
       <p:grpSpPr/>
       <p:pic>
         <p:nvPicPr>
-          <p:cNvPr id="2" name="Picture 1" descr="tech-bg-3.jpg"/>
+          <p:cNvPr id="2" name="Picture 1" descr="scene-07.jpg"/>
           <p:cNvPicPr>
             <a:picLocks noChangeAspect="1"/>
           </p:cNvPicPr>
@@ -25879,8 +26008,8 @@
         </p:blipFill>
         <p:spPr>
           <a:xfrm>
-            <a:off x="0" y="0"/>
-            <a:ext cx="12191695" cy="6858000"/>
+            <a:off x="7818120" y="0"/>
+            <a:ext cx="4370832" cy="6858000"/>
           </a:xfrm>
           <a:prstGeom prst="rect">
             <a:avLst/>
@@ -25895,8 +26024,8 @@
         </p:nvSpPr>
         <p:spPr>
           <a:xfrm>
-            <a:off x="0" y="0"/>
-            <a:ext cx="12191695" cy="6858000"/>
+            <a:off x="7699248" y="0"/>
+            <a:ext cx="4526280" cy="6858000"/>
           </a:xfrm>
           <a:prstGeom prst="rect">
             <a:avLst/>
@@ -27958,7 +28087,7 @@
       <p:grpSpPr/>
       <p:pic>
         <p:nvPicPr>
-          <p:cNvPr id="2" name="Picture 1" descr="tech-bg-2.jpg"/>
+          <p:cNvPr id="2" name="Picture 1" descr="scene-02.jpg"/>
           <p:cNvPicPr>
             <a:picLocks noChangeAspect="1"/>
           </p:cNvPicPr>
@@ -30748,7 +30877,7 @@
       <p:grpSpPr/>
       <p:pic>
         <p:nvPicPr>
-          <p:cNvPr id="2" name="Picture 1" descr="tech-bg-4.jpg"/>
+          <p:cNvPr id="2" name="Picture 1" descr="scene-08.jpg"/>
           <p:cNvPicPr>
             <a:picLocks noChangeAspect="1"/>
           </p:cNvPicPr>
@@ -32841,7 +32970,7 @@
       <p:grpSpPr/>
       <p:pic>
         <p:nvPicPr>
-          <p:cNvPr id="2" name="Picture 1" descr="tech-bg-3.jpg"/>
+          <p:cNvPr id="2" name="Picture 1" descr="scene-03.jpg"/>
           <p:cNvPicPr>
             <a:picLocks noChangeAspect="1"/>
           </p:cNvPicPr>
@@ -32855,28 +32984,114 @@
         </p:blipFill>
         <p:spPr>
           <a:xfrm>
+            <a:off x="4754880" y="0"/>
+            <a:ext cx="7452360" cy="6858000"/>
+          </a:xfrm>
+          <a:prstGeom prst="rect">
+            <a:avLst/>
+          </a:prstGeom>
+        </p:spPr>
+      </p:pic>
+      <p:sp>
+        <p:nvSpPr>
+          <p:cNvPr id="3" name="Chevron 2"/>
+          <p:cNvSpPr/>
+          <p:nvPr/>
+        </p:nvSpPr>
+        <p:spPr>
+          <a:xfrm>
+            <a:off x="4434840" y="45720"/>
+            <a:ext cx="2423160" cy="6720840"/>
+          </a:xfrm>
+          <a:prstGeom prst="chevron">
+            <a:avLst/>
+          </a:prstGeom>
+          <a:solidFill>
+            <a:srgbClr val="E6EEFA"/>
+          </a:solidFill>
+          <a:ln>
+            <a:noFill/>
+          </a:ln>
+        </p:spPr>
+        <p:style>
+          <a:lnRef idx="1">
+            <a:schemeClr val="accent1"/>
+          </a:lnRef>
+          <a:fillRef idx="3">
+            <a:schemeClr val="accent1"/>
+          </a:fillRef>
+          <a:effectRef idx="2">
+            <a:schemeClr val="accent1"/>
+          </a:effectRef>
+          <a:fontRef idx="minor">
+            <a:schemeClr val="lt1"/>
+          </a:fontRef>
+        </p:style>
+        <p:txBody>
+          <a:bodyPr rtlCol="0" anchor="ctr"/>
+          <a:lstStyle/>
+          <a:p>
+            <a:pPr algn="ctr"/>
+          </a:p>
+        </p:txBody>
+      </p:sp>
+      <p:sp>
+        <p:nvSpPr>
+          <p:cNvPr id="4" name="Rectangle 3"/>
+          <p:cNvSpPr/>
+          <p:nvPr/>
+        </p:nvSpPr>
+        <p:spPr>
+          <a:xfrm>
+            <a:off x="4663440" y="0"/>
+            <a:ext cx="7543800" cy="6858000"/>
+          </a:xfrm>
+          <a:prstGeom prst="rect">
+            <a:avLst/>
+          </a:prstGeom>
+          <a:solidFill>
+            <a:srgbClr val="FFFFFF"/>
+          </a:solidFill>
+          <a:ln>
+            <a:noFill/>
+          </a:ln>
+        </p:spPr>
+        <p:style>
+          <a:lnRef idx="1">
+            <a:schemeClr val="accent1"/>
+          </a:lnRef>
+          <a:fillRef idx="3">
+            <a:schemeClr val="accent1"/>
+          </a:fillRef>
+          <a:effectRef idx="2">
+            <a:schemeClr val="accent1"/>
+          </a:effectRef>
+          <a:fontRef idx="minor">
+            <a:schemeClr val="lt1"/>
+          </a:fontRef>
+        </p:style>
+        <p:txBody>
+          <a:bodyPr rtlCol="0" anchor="ctr"/>
+          <a:lstStyle/>
+          <a:p>
+            <a:pPr algn="ctr"/>
+          </a:p>
+        </p:txBody>
+      </p:sp>
+      <p:sp>
+        <p:nvSpPr>
+          <p:cNvPr id="5" name="Rectangle 4"/>
+          <p:cNvSpPr/>
+          <p:nvPr/>
+        </p:nvSpPr>
+        <p:spPr>
+          <a:xfrm>
             <a:off x="0" y="0"/>
             <a:ext cx="12191695" cy="6858000"/>
           </a:xfrm>
           <a:prstGeom prst="rect">
             <a:avLst/>
           </a:prstGeom>
-        </p:spPr>
-      </p:pic>
-      <p:sp>
-        <p:nvSpPr>
-          <p:cNvPr id="3" name="Rectangle 2"/>
-          <p:cNvSpPr/>
-          <p:nvPr/>
-        </p:nvSpPr>
-        <p:spPr>
-          <a:xfrm>
-            <a:off x="0" y="0"/>
-            <a:ext cx="12191695" cy="6858000"/>
-          </a:xfrm>
-          <a:prstGeom prst="rect">
-            <a:avLst/>
-          </a:prstGeom>
           <a:solidFill>
             <a:srgbClr val="FFFFFF"/>
           </a:solidFill>
@@ -32908,50 +33123,7 @@
       </p:sp>
       <p:sp>
         <p:nvSpPr>
-          <p:cNvPr id="4" name="Rectangle 3"/>
-          <p:cNvSpPr/>
-          <p:nvPr/>
-        </p:nvSpPr>
-        <p:spPr>
-          <a:xfrm>
-            <a:off x="0" y="0"/>
-            <a:ext cx="12191695" cy="6858000"/>
-          </a:xfrm>
-          <a:prstGeom prst="rect">
-            <a:avLst/>
-          </a:prstGeom>
-          <a:solidFill>
-            <a:srgbClr val="FFFFFF"/>
-          </a:solidFill>
-          <a:ln>
-            <a:noFill/>
-          </a:ln>
-        </p:spPr>
-        <p:style>
-          <a:lnRef idx="1">
-            <a:schemeClr val="accent1"/>
-          </a:lnRef>
-          <a:fillRef idx="3">
-            <a:schemeClr val="accent1"/>
-          </a:fillRef>
-          <a:effectRef idx="2">
-            <a:schemeClr val="accent1"/>
-          </a:effectRef>
-          <a:fontRef idx="minor">
-            <a:schemeClr val="lt1"/>
-          </a:fontRef>
-        </p:style>
-        <p:txBody>
-          <a:bodyPr rtlCol="0" anchor="ctr"/>
-          <a:lstStyle/>
-          <a:p>
-            <a:pPr algn="ctr"/>
-          </a:p>
-        </p:txBody>
-      </p:sp>
-      <p:sp>
-        <p:nvSpPr>
-          <p:cNvPr id="5" name="Rectangle 4"/>
+          <p:cNvPr id="6" name="Rectangle 5"/>
           <p:cNvSpPr/>
           <p:nvPr/>
         </p:nvSpPr>
@@ -32994,7 +33166,7 @@
       </p:sp>
       <p:sp>
         <p:nvSpPr>
-          <p:cNvPr id="6" name="Rectangle 5"/>
+          <p:cNvPr id="7" name="Rectangle 6"/>
           <p:cNvSpPr/>
           <p:nvPr/>
         </p:nvSpPr>
@@ -33037,7 +33209,7 @@
       </p:sp>
       <p:sp>
         <p:nvSpPr>
-          <p:cNvPr id="7" name="Rectangle 6"/>
+          <p:cNvPr id="8" name="Rectangle 7"/>
           <p:cNvSpPr/>
           <p:nvPr/>
         </p:nvSpPr>
@@ -33080,7 +33252,7 @@
       </p:sp>
       <p:sp>
         <p:nvSpPr>
-          <p:cNvPr id="8" name="Rectangle 7"/>
+          <p:cNvPr id="9" name="Rectangle 8"/>
           <p:cNvSpPr/>
           <p:nvPr/>
         </p:nvSpPr>
@@ -33123,7 +33295,7 @@
       </p:sp>
       <p:sp>
         <p:nvSpPr>
-          <p:cNvPr id="9" name="Oval 8"/>
+          <p:cNvPr id="10" name="Oval 9"/>
           <p:cNvSpPr/>
           <p:nvPr/>
         </p:nvSpPr>
@@ -33166,7 +33338,7 @@
       </p:sp>
       <p:sp>
         <p:nvSpPr>
-          <p:cNvPr id="10" name="Oval 9"/>
+          <p:cNvPr id="11" name="Oval 10"/>
           <p:cNvSpPr/>
           <p:nvPr/>
         </p:nvSpPr>
@@ -33209,7 +33381,7 @@
       </p:sp>
       <p:sp>
         <p:nvSpPr>
-          <p:cNvPr id="11" name="Rectangle 10"/>
+          <p:cNvPr id="12" name="Rectangle 11"/>
           <p:cNvSpPr/>
           <p:nvPr/>
         </p:nvSpPr>
@@ -33252,7 +33424,7 @@
       </p:sp>
       <p:sp>
         <p:nvSpPr>
-          <p:cNvPr id="12" name="Rectangle 11"/>
+          <p:cNvPr id="13" name="Rectangle 12"/>
           <p:cNvSpPr/>
           <p:nvPr/>
         </p:nvSpPr>
@@ -33295,7 +33467,7 @@
       </p:sp>
       <p:sp>
         <p:nvSpPr>
-          <p:cNvPr id="13" name="Rectangle 12"/>
+          <p:cNvPr id="14" name="Rectangle 13"/>
           <p:cNvSpPr/>
           <p:nvPr/>
         </p:nvSpPr>
@@ -33338,7 +33510,7 @@
       </p:sp>
       <p:sp>
         <p:nvSpPr>
-          <p:cNvPr id="14" name="Rectangle 13"/>
+          <p:cNvPr id="15" name="Rectangle 14"/>
           <p:cNvSpPr/>
           <p:nvPr/>
         </p:nvSpPr>
@@ -33381,7 +33553,7 @@
       </p:sp>
       <p:sp>
         <p:nvSpPr>
-          <p:cNvPr id="15" name="Rectangle 14"/>
+          <p:cNvPr id="16" name="Rectangle 15"/>
           <p:cNvSpPr/>
           <p:nvPr/>
         </p:nvSpPr>
@@ -33424,7 +33596,7 @@
       </p:sp>
       <p:sp>
         <p:nvSpPr>
-          <p:cNvPr id="16" name="Rectangle 15"/>
+          <p:cNvPr id="17" name="Rectangle 16"/>
           <p:cNvSpPr/>
           <p:nvPr/>
         </p:nvSpPr>
@@ -33467,7 +33639,7 @@
       </p:sp>
       <p:sp>
         <p:nvSpPr>
-          <p:cNvPr id="17" name="Rectangle 16"/>
+          <p:cNvPr id="18" name="Rectangle 17"/>
           <p:cNvSpPr/>
           <p:nvPr/>
         </p:nvSpPr>
@@ -33510,7 +33682,7 @@
       </p:sp>
       <p:sp>
         <p:nvSpPr>
-          <p:cNvPr id="18" name="Arc 17"/>
+          <p:cNvPr id="19" name="Arc 18"/>
           <p:cNvSpPr/>
           <p:nvPr/>
         </p:nvSpPr>
@@ -33553,7 +33725,7 @@
       </p:sp>
       <p:sp>
         <p:nvSpPr>
-          <p:cNvPr id="19" name="Rectangle 18"/>
+          <p:cNvPr id="20" name="Rectangle 19"/>
           <p:cNvSpPr/>
           <p:nvPr/>
         </p:nvSpPr>
@@ -33596,7 +33768,7 @@
       </p:sp>
       <p:sp>
         <p:nvSpPr>
-          <p:cNvPr id="20" name="Rectangle 19"/>
+          <p:cNvPr id="21" name="Rectangle 20"/>
           <p:cNvSpPr/>
           <p:nvPr/>
         </p:nvSpPr>
@@ -33639,7 +33811,7 @@
       </p:sp>
       <p:sp>
         <p:nvSpPr>
-          <p:cNvPr id="21" name="Rectangle 20"/>
+          <p:cNvPr id="22" name="Rectangle 21"/>
           <p:cNvSpPr/>
           <p:nvPr/>
         </p:nvSpPr>
@@ -33682,7 +33854,7 @@
       </p:sp>
       <p:sp>
         <p:nvSpPr>
-          <p:cNvPr id="22" name="Rectangle 21"/>
+          <p:cNvPr id="23" name="Rectangle 22"/>
           <p:cNvSpPr/>
           <p:nvPr/>
         </p:nvSpPr>
@@ -33725,7 +33897,7 @@
       </p:sp>
       <p:sp>
         <p:nvSpPr>
-          <p:cNvPr id="23" name="TextBox 22"/>
+          <p:cNvPr id="24" name="TextBox 23"/>
           <p:cNvSpPr txBox="1"/>
           <p:nvPr/>
         </p:nvSpPr>
@@ -33759,7 +33931,7 @@
       </p:sp>
       <p:sp>
         <p:nvSpPr>
-          <p:cNvPr id="24" name="Rectangle 23"/>
+          <p:cNvPr id="25" name="Rectangle 24"/>
           <p:cNvSpPr/>
           <p:nvPr/>
         </p:nvSpPr>
@@ -33802,7 +33974,7 @@
       </p:sp>
       <p:sp>
         <p:nvSpPr>
-          <p:cNvPr id="25" name="Rounded Rectangle 24"/>
+          <p:cNvPr id="26" name="Rounded Rectangle 25"/>
           <p:cNvSpPr/>
           <p:nvPr/>
         </p:nvSpPr>
@@ -33847,7 +34019,7 @@
       </p:sp>
       <p:sp>
         <p:nvSpPr>
-          <p:cNvPr id="26" name="Rounded Rectangle 25"/>
+          <p:cNvPr id="27" name="Rounded Rectangle 26"/>
           <p:cNvSpPr/>
           <p:nvPr/>
         </p:nvSpPr>
@@ -33894,7 +34066,7 @@
       </p:sp>
       <p:sp>
         <p:nvSpPr>
-          <p:cNvPr id="27" name="Rectangle 26"/>
+          <p:cNvPr id="28" name="Rectangle 27"/>
           <p:cNvSpPr/>
           <p:nvPr/>
         </p:nvSpPr>
@@ -33937,7 +34109,7 @@
       </p:sp>
       <p:sp>
         <p:nvSpPr>
-          <p:cNvPr id="28" name="TextBox 27"/>
+          <p:cNvPr id="29" name="TextBox 28"/>
           <p:cNvSpPr txBox="1"/>
           <p:nvPr/>
         </p:nvSpPr>
@@ -33971,7 +34143,7 @@
       </p:sp>
       <p:sp>
         <p:nvSpPr>
-          <p:cNvPr id="29" name="TextBox 28"/>
+          <p:cNvPr id="30" name="TextBox 29"/>
           <p:cNvSpPr txBox="1"/>
           <p:nvPr/>
         </p:nvSpPr>
@@ -34005,7 +34177,7 @@
       </p:sp>
       <p:sp>
         <p:nvSpPr>
-          <p:cNvPr id="30" name="TextBox 29"/>
+          <p:cNvPr id="31" name="TextBox 30"/>
           <p:cNvSpPr txBox="1"/>
           <p:nvPr/>
         </p:nvSpPr>
@@ -34039,7 +34211,7 @@
       </p:sp>
       <p:sp>
         <p:nvSpPr>
-          <p:cNvPr id="31" name="TextBox 30"/>
+          <p:cNvPr id="32" name="TextBox 31"/>
           <p:cNvSpPr txBox="1"/>
           <p:nvPr/>
         </p:nvSpPr>
@@ -34073,7 +34245,7 @@
       </p:sp>
       <p:sp>
         <p:nvSpPr>
-          <p:cNvPr id="32" name="Rectangle 31"/>
+          <p:cNvPr id="33" name="Rectangle 32"/>
           <p:cNvSpPr/>
           <p:nvPr/>
         </p:nvSpPr>
@@ -34116,7 +34288,7 @@
       </p:sp>
       <p:sp>
         <p:nvSpPr>
-          <p:cNvPr id="33" name="TextBox 32"/>
+          <p:cNvPr id="34" name="TextBox 33"/>
           <p:cNvSpPr txBox="1"/>
           <p:nvPr/>
         </p:nvSpPr>
@@ -34150,7 +34322,7 @@
       </p:sp>
       <p:sp>
         <p:nvSpPr>
-          <p:cNvPr id="34" name="TextBox 33"/>
+          <p:cNvPr id="35" name="TextBox 34"/>
           <p:cNvSpPr txBox="1"/>
           <p:nvPr/>
         </p:nvSpPr>
@@ -34184,7 +34356,7 @@
       </p:sp>
       <p:sp>
         <p:nvSpPr>
-          <p:cNvPr id="35" name="Rectangle 34"/>
+          <p:cNvPr id="36" name="Rectangle 35"/>
           <p:cNvSpPr/>
           <p:nvPr/>
         </p:nvSpPr>
@@ -34227,7 +34399,7 @@
       </p:sp>
       <p:sp>
         <p:nvSpPr>
-          <p:cNvPr id="36" name="TextBox 35"/>
+          <p:cNvPr id="37" name="TextBox 36"/>
           <p:cNvSpPr txBox="1"/>
           <p:nvPr/>
         </p:nvSpPr>
@@ -34261,7 +34433,7 @@
       </p:sp>
       <p:sp>
         <p:nvSpPr>
-          <p:cNvPr id="37" name="TextBox 36"/>
+          <p:cNvPr id="38" name="TextBox 37"/>
           <p:cNvSpPr txBox="1"/>
           <p:nvPr/>
         </p:nvSpPr>
@@ -34295,7 +34467,7 @@
       </p:sp>
       <p:sp>
         <p:nvSpPr>
-          <p:cNvPr id="38" name="Rectangle 37"/>
+          <p:cNvPr id="39" name="Rectangle 38"/>
           <p:cNvSpPr/>
           <p:nvPr/>
         </p:nvSpPr>
@@ -34338,7 +34510,7 @@
       </p:sp>
       <p:sp>
         <p:nvSpPr>
-          <p:cNvPr id="39" name="TextBox 38"/>
+          <p:cNvPr id="40" name="TextBox 39"/>
           <p:cNvSpPr txBox="1"/>
           <p:nvPr/>
         </p:nvSpPr>
@@ -34372,7 +34544,7 @@
       </p:sp>
       <p:sp>
         <p:nvSpPr>
-          <p:cNvPr id="40" name="TextBox 39"/>
+          <p:cNvPr id="41" name="TextBox 40"/>
           <p:cNvSpPr txBox="1"/>
           <p:nvPr/>
         </p:nvSpPr>
@@ -34406,7 +34578,7 @@
       </p:sp>
       <p:sp>
         <p:nvSpPr>
-          <p:cNvPr id="41" name="Rectangle 40"/>
+          <p:cNvPr id="42" name="Rectangle 41"/>
           <p:cNvSpPr/>
           <p:nvPr/>
         </p:nvSpPr>
@@ -34449,7 +34621,7 @@
       </p:sp>
       <p:sp>
         <p:nvSpPr>
-          <p:cNvPr id="42" name="TextBox 41"/>
+          <p:cNvPr id="43" name="TextBox 42"/>
           <p:cNvSpPr txBox="1"/>
           <p:nvPr/>
         </p:nvSpPr>
@@ -34483,7 +34655,7 @@
       </p:sp>
       <p:sp>
         <p:nvSpPr>
-          <p:cNvPr id="43" name="TextBox 42"/>
+          <p:cNvPr id="44" name="TextBox 43"/>
           <p:cNvSpPr txBox="1"/>
           <p:nvPr/>
         </p:nvSpPr>
@@ -34517,7 +34689,7 @@
       </p:sp>
       <p:sp>
         <p:nvSpPr>
-          <p:cNvPr id="44" name="Rounded Rectangle 43"/>
+          <p:cNvPr id="45" name="Rounded Rectangle 44"/>
           <p:cNvSpPr/>
           <p:nvPr/>
         </p:nvSpPr>
@@ -34562,7 +34734,7 @@
       </p:sp>
       <p:sp>
         <p:nvSpPr>
-          <p:cNvPr id="45" name="Rounded Rectangle 44"/>
+          <p:cNvPr id="46" name="Rounded Rectangle 45"/>
           <p:cNvSpPr/>
           <p:nvPr/>
         </p:nvSpPr>
@@ -34618,7 +34790,7 @@
       </p:sp>
       <p:sp>
         <p:nvSpPr>
-          <p:cNvPr id="46" name="Rounded Rectangle 45"/>
+          <p:cNvPr id="47" name="Rounded Rectangle 46"/>
           <p:cNvSpPr/>
           <p:nvPr/>
         </p:nvSpPr>
@@ -34663,7 +34835,7 @@
       </p:sp>
       <p:sp>
         <p:nvSpPr>
-          <p:cNvPr id="47" name="Rectangle 46"/>
+          <p:cNvPr id="48" name="Rectangle 47"/>
           <p:cNvSpPr/>
           <p:nvPr/>
         </p:nvSpPr>
@@ -34706,7 +34878,7 @@
       </p:sp>
       <p:sp>
         <p:nvSpPr>
-          <p:cNvPr id="48" name="Rectangle 47"/>
+          <p:cNvPr id="49" name="Rectangle 48"/>
           <p:cNvSpPr/>
           <p:nvPr/>
         </p:nvSpPr>
@@ -34749,7 +34921,7 @@
       </p:sp>
       <p:sp>
         <p:nvSpPr>
-          <p:cNvPr id="49" name="Rectangle 48"/>
+          <p:cNvPr id="50" name="Rectangle 49"/>
           <p:cNvSpPr/>
           <p:nvPr/>
         </p:nvSpPr>
@@ -34792,7 +34964,7 @@
       </p:sp>
       <p:sp>
         <p:nvSpPr>
-          <p:cNvPr id="50" name="Rectangle 49"/>
+          <p:cNvPr id="51" name="Rectangle 50"/>
           <p:cNvSpPr/>
           <p:nvPr/>
         </p:nvSpPr>
@@ -34835,7 +35007,7 @@
       </p:sp>
       <p:sp>
         <p:nvSpPr>
-          <p:cNvPr id="51" name="Rectangle 50"/>
+          <p:cNvPr id="52" name="Rectangle 51"/>
           <p:cNvSpPr/>
           <p:nvPr/>
         </p:nvSpPr>
@@ -34878,7 +35050,7 @@
       </p:sp>
       <p:sp>
         <p:nvSpPr>
-          <p:cNvPr id="52" name="Rectangle 51"/>
+          <p:cNvPr id="53" name="Rectangle 52"/>
           <p:cNvSpPr/>
           <p:nvPr/>
         </p:nvSpPr>
@@ -34921,7 +35093,7 @@
       </p:sp>
       <p:sp>
         <p:nvSpPr>
-          <p:cNvPr id="53" name="Rectangle 52"/>
+          <p:cNvPr id="54" name="Rectangle 53"/>
           <p:cNvSpPr/>
           <p:nvPr/>
         </p:nvSpPr>
@@ -34964,7 +35136,7 @@
       </p:sp>
       <p:sp>
         <p:nvSpPr>
-          <p:cNvPr id="54" name="TextBox 53"/>
+          <p:cNvPr id="55" name="TextBox 54"/>
           <p:cNvSpPr txBox="1"/>
           <p:nvPr/>
         </p:nvSpPr>
@@ -34998,7 +35170,7 @@
       </p:sp>
       <p:sp>
         <p:nvSpPr>
-          <p:cNvPr id="55" name="Rectangle 54"/>
+          <p:cNvPr id="56" name="Rectangle 55"/>
           <p:cNvSpPr/>
           <p:nvPr/>
         </p:nvSpPr>
@@ -35041,7 +35213,7 @@
       </p:sp>
       <p:sp>
         <p:nvSpPr>
-          <p:cNvPr id="56" name="TextBox 55"/>
+          <p:cNvPr id="57" name="TextBox 56"/>
           <p:cNvSpPr txBox="1"/>
           <p:nvPr/>
         </p:nvSpPr>
@@ -35075,7 +35247,7 @@
       </p:sp>
       <p:sp>
         <p:nvSpPr>
-          <p:cNvPr id="57" name="Rectangle 56"/>
+          <p:cNvPr id="58" name="Rectangle 57"/>
           <p:cNvSpPr/>
           <p:nvPr/>
         </p:nvSpPr>
@@ -35118,7 +35290,7 @@
       </p:sp>
       <p:sp>
         <p:nvSpPr>
-          <p:cNvPr id="58" name="Arc 57"/>
+          <p:cNvPr id="59" name="Arc 58"/>
           <p:cNvSpPr/>
           <p:nvPr/>
         </p:nvSpPr>
@@ -35161,7 +35333,7 @@
       </p:sp>
       <p:pic>
         <p:nvPicPr>
-          <p:cNvPr id="59" name="Picture 58" descr="go.png"/>
+          <p:cNvPr id="60" name="Picture 59" descr="go.png"/>
           <p:cNvPicPr>
             <a:picLocks noChangeAspect="1"/>
           </p:cNvPicPr>
@@ -35185,7 +35357,7 @@
       </p:pic>
       <p:pic>
         <p:nvPicPr>
-          <p:cNvPr id="60" name="Picture 59" descr="mysql.png"/>
+          <p:cNvPr id="61" name="Picture 60" descr="mysql.png"/>
           <p:cNvPicPr>
             <a:picLocks noChangeAspect="1"/>
           </p:cNvPicPr>
@@ -35209,7 +35381,7 @@
       </p:pic>
       <p:pic>
         <p:nvPicPr>
-          <p:cNvPr id="61" name="Picture 60" descr="redis.png"/>
+          <p:cNvPr id="62" name="Picture 61" descr="redis.png"/>
           <p:cNvPicPr>
             <a:picLocks noChangeAspect="1"/>
           </p:cNvPicPr>
@@ -35233,7 +35405,7 @@
       </p:pic>
       <p:sp>
         <p:nvSpPr>
-          <p:cNvPr id="62" name="Rectangle 61"/>
+          <p:cNvPr id="63" name="Rectangle 62"/>
           <p:cNvSpPr/>
           <p:nvPr/>
         </p:nvSpPr>
@@ -35276,7 +35448,7 @@
       </p:sp>
       <p:sp>
         <p:nvSpPr>
-          <p:cNvPr id="63" name="TextBox 62"/>
+          <p:cNvPr id="64" name="TextBox 63"/>
           <p:cNvSpPr txBox="1"/>
           <p:nvPr/>
         </p:nvSpPr>
@@ -35310,7 +35482,7 @@
       </p:sp>
       <p:sp>
         <p:nvSpPr>
-          <p:cNvPr id="64" name="TextBox 63"/>
+          <p:cNvPr id="65" name="TextBox 64"/>
           <p:cNvSpPr txBox="1"/>
           <p:nvPr/>
         </p:nvSpPr>
@@ -35371,7 +35543,7 @@
       <p:grpSpPr/>
       <p:pic>
         <p:nvPicPr>
-          <p:cNvPr id="2" name="Picture 1" descr="tech-bg-4.jpg"/>
+          <p:cNvPr id="2" name="Picture 1" descr="scene-04.jpg"/>
           <p:cNvPicPr>
             <a:picLocks noChangeAspect="1"/>
           </p:cNvPicPr>
@@ -35385,8 +35557,8 @@
         </p:blipFill>
         <p:spPr>
           <a:xfrm>
-            <a:off x="0" y="0"/>
-            <a:ext cx="12191695" cy="6858000"/>
+            <a:off x="7818120" y="0"/>
+            <a:ext cx="4370832" cy="6858000"/>
           </a:xfrm>
           <a:prstGeom prst="rect">
             <a:avLst/>
@@ -35401,8 +35573,8 @@
         </p:nvSpPr>
         <p:spPr>
           <a:xfrm>
-            <a:off x="0" y="0"/>
-            <a:ext cx="12191695" cy="6858000"/>
+            <a:off x="7699248" y="0"/>
+            <a:ext cx="4526280" cy="6858000"/>
           </a:xfrm>
           <a:prstGeom prst="rect">
             <a:avLst/>
@@ -37488,7 +37660,7 @@
       <p:grpSpPr/>
       <p:pic>
         <p:nvPicPr>
-          <p:cNvPr id="2" name="Picture 1" descr="tech-bg-5.jpg"/>
+          <p:cNvPr id="2" name="Picture 1" descr="scene-05.jpg"/>
           <p:cNvPicPr>
             <a:picLocks noChangeAspect="1"/>
           </p:cNvPicPr>
@@ -39835,7 +40007,7 @@
       <p:grpSpPr/>
       <p:pic>
         <p:nvPicPr>
-          <p:cNvPr id="2" name="Picture 1" descr="tech-bg-6.jpg"/>
+          <p:cNvPr id="2" name="Picture 1" descr="scene-06.jpg"/>
           <p:cNvPicPr>
             <a:picLocks noChangeAspect="1"/>
           </p:cNvPicPr>
@@ -39849,28 +40021,114 @@
         </p:blipFill>
         <p:spPr>
           <a:xfrm>
+            <a:off x="4754880" y="0"/>
+            <a:ext cx="7452360" cy="6858000"/>
+          </a:xfrm>
+          <a:prstGeom prst="rect">
+            <a:avLst/>
+          </a:prstGeom>
+        </p:spPr>
+      </p:pic>
+      <p:sp>
+        <p:nvSpPr>
+          <p:cNvPr id="3" name="Chevron 2"/>
+          <p:cNvSpPr/>
+          <p:nvPr/>
+        </p:nvSpPr>
+        <p:spPr>
+          <a:xfrm>
+            <a:off x="4434840" y="45720"/>
+            <a:ext cx="2423160" cy="6720840"/>
+          </a:xfrm>
+          <a:prstGeom prst="chevron">
+            <a:avLst/>
+          </a:prstGeom>
+          <a:solidFill>
+            <a:srgbClr val="E6EEFA"/>
+          </a:solidFill>
+          <a:ln>
+            <a:noFill/>
+          </a:ln>
+        </p:spPr>
+        <p:style>
+          <a:lnRef idx="1">
+            <a:schemeClr val="accent1"/>
+          </a:lnRef>
+          <a:fillRef idx="3">
+            <a:schemeClr val="accent1"/>
+          </a:fillRef>
+          <a:effectRef idx="2">
+            <a:schemeClr val="accent1"/>
+          </a:effectRef>
+          <a:fontRef idx="minor">
+            <a:schemeClr val="lt1"/>
+          </a:fontRef>
+        </p:style>
+        <p:txBody>
+          <a:bodyPr rtlCol="0" anchor="ctr"/>
+          <a:lstStyle/>
+          <a:p>
+            <a:pPr algn="ctr"/>
+          </a:p>
+        </p:txBody>
+      </p:sp>
+      <p:sp>
+        <p:nvSpPr>
+          <p:cNvPr id="4" name="Rectangle 3"/>
+          <p:cNvSpPr/>
+          <p:nvPr/>
+        </p:nvSpPr>
+        <p:spPr>
+          <a:xfrm>
+            <a:off x="4663440" y="0"/>
+            <a:ext cx="7543800" cy="6858000"/>
+          </a:xfrm>
+          <a:prstGeom prst="rect">
+            <a:avLst/>
+          </a:prstGeom>
+          <a:solidFill>
+            <a:srgbClr val="FFFFFF"/>
+          </a:solidFill>
+          <a:ln>
+            <a:noFill/>
+          </a:ln>
+        </p:spPr>
+        <p:style>
+          <a:lnRef idx="1">
+            <a:schemeClr val="accent1"/>
+          </a:lnRef>
+          <a:fillRef idx="3">
+            <a:schemeClr val="accent1"/>
+          </a:fillRef>
+          <a:effectRef idx="2">
+            <a:schemeClr val="accent1"/>
+          </a:effectRef>
+          <a:fontRef idx="minor">
+            <a:schemeClr val="lt1"/>
+          </a:fontRef>
+        </p:style>
+        <p:txBody>
+          <a:bodyPr rtlCol="0" anchor="ctr"/>
+          <a:lstStyle/>
+          <a:p>
+            <a:pPr algn="ctr"/>
+          </a:p>
+        </p:txBody>
+      </p:sp>
+      <p:sp>
+        <p:nvSpPr>
+          <p:cNvPr id="5" name="Rectangle 4"/>
+          <p:cNvSpPr/>
+          <p:nvPr/>
+        </p:nvSpPr>
+        <p:spPr>
+          <a:xfrm>
             <a:off x="0" y="0"/>
             <a:ext cx="12191695" cy="6858000"/>
           </a:xfrm>
           <a:prstGeom prst="rect">
             <a:avLst/>
           </a:prstGeom>
-        </p:spPr>
-      </p:pic>
-      <p:sp>
-        <p:nvSpPr>
-          <p:cNvPr id="3" name="Rectangle 2"/>
-          <p:cNvSpPr/>
-          <p:nvPr/>
-        </p:nvSpPr>
-        <p:spPr>
-          <a:xfrm>
-            <a:off x="0" y="0"/>
-            <a:ext cx="12191695" cy="6858000"/>
-          </a:xfrm>
-          <a:prstGeom prst="rect">
-            <a:avLst/>
-          </a:prstGeom>
           <a:solidFill>
             <a:srgbClr val="FFFFFF"/>
           </a:solidFill>
@@ -39902,50 +40160,7 @@
       </p:sp>
       <p:sp>
         <p:nvSpPr>
-          <p:cNvPr id="4" name="Rectangle 3"/>
-          <p:cNvSpPr/>
-          <p:nvPr/>
-        </p:nvSpPr>
-        <p:spPr>
-          <a:xfrm>
-            <a:off x="0" y="0"/>
-            <a:ext cx="12191695" cy="6858000"/>
-          </a:xfrm>
-          <a:prstGeom prst="rect">
-            <a:avLst/>
-          </a:prstGeom>
-          <a:solidFill>
-            <a:srgbClr val="FFFFFF"/>
-          </a:solidFill>
-          <a:ln>
-            <a:noFill/>
-          </a:ln>
-        </p:spPr>
-        <p:style>
-          <a:lnRef idx="1">
-            <a:schemeClr val="accent1"/>
-          </a:lnRef>
-          <a:fillRef idx="3">
-            <a:schemeClr val="accent1"/>
-          </a:fillRef>
-          <a:effectRef idx="2">
-            <a:schemeClr val="accent1"/>
-          </a:effectRef>
-          <a:fontRef idx="minor">
-            <a:schemeClr val="lt1"/>
-          </a:fontRef>
-        </p:style>
-        <p:txBody>
-          <a:bodyPr rtlCol="0" anchor="ctr"/>
-          <a:lstStyle/>
-          <a:p>
-            <a:pPr algn="ctr"/>
-          </a:p>
-        </p:txBody>
-      </p:sp>
-      <p:sp>
-        <p:nvSpPr>
-          <p:cNvPr id="5" name="Rectangle 4"/>
+          <p:cNvPr id="6" name="Rectangle 5"/>
           <p:cNvSpPr/>
           <p:nvPr/>
         </p:nvSpPr>
@@ -39988,7 +40203,7 @@
       </p:sp>
       <p:sp>
         <p:nvSpPr>
-          <p:cNvPr id="6" name="Rectangle 5"/>
+          <p:cNvPr id="7" name="Rectangle 6"/>
           <p:cNvSpPr/>
           <p:nvPr/>
         </p:nvSpPr>
@@ -40031,7 +40246,7 @@
       </p:sp>
       <p:sp>
         <p:nvSpPr>
-          <p:cNvPr id="7" name="Rectangle 6"/>
+          <p:cNvPr id="8" name="Rectangle 7"/>
           <p:cNvSpPr/>
           <p:nvPr/>
         </p:nvSpPr>
@@ -40074,7 +40289,7 @@
       </p:sp>
       <p:sp>
         <p:nvSpPr>
-          <p:cNvPr id="8" name="Rectangle 7"/>
+          <p:cNvPr id="9" name="Rectangle 8"/>
           <p:cNvSpPr/>
           <p:nvPr/>
         </p:nvSpPr>
@@ -40117,7 +40332,7 @@
       </p:sp>
       <p:sp>
         <p:nvSpPr>
-          <p:cNvPr id="9" name="Oval 8"/>
+          <p:cNvPr id="10" name="Oval 9"/>
           <p:cNvSpPr/>
           <p:nvPr/>
         </p:nvSpPr>
@@ -40160,7 +40375,7 @@
       </p:sp>
       <p:sp>
         <p:nvSpPr>
-          <p:cNvPr id="10" name="Oval 9"/>
+          <p:cNvPr id="11" name="Oval 10"/>
           <p:cNvSpPr/>
           <p:nvPr/>
         </p:nvSpPr>
@@ -40203,7 +40418,7 @@
       </p:sp>
       <p:sp>
         <p:nvSpPr>
-          <p:cNvPr id="11" name="Rectangle 10"/>
+          <p:cNvPr id="12" name="Rectangle 11"/>
           <p:cNvSpPr/>
           <p:nvPr/>
         </p:nvSpPr>
@@ -40246,7 +40461,7 @@
       </p:sp>
       <p:sp>
         <p:nvSpPr>
-          <p:cNvPr id="12" name="Rectangle 11"/>
+          <p:cNvPr id="13" name="Rectangle 12"/>
           <p:cNvSpPr/>
           <p:nvPr/>
         </p:nvSpPr>
@@ -40289,7 +40504,7 @@
       </p:sp>
       <p:sp>
         <p:nvSpPr>
-          <p:cNvPr id="13" name="Rectangle 12"/>
+          <p:cNvPr id="14" name="Rectangle 13"/>
           <p:cNvSpPr/>
           <p:nvPr/>
         </p:nvSpPr>
@@ -40332,7 +40547,7 @@
       </p:sp>
       <p:sp>
         <p:nvSpPr>
-          <p:cNvPr id="14" name="Rectangle 13"/>
+          <p:cNvPr id="15" name="Rectangle 14"/>
           <p:cNvSpPr/>
           <p:nvPr/>
         </p:nvSpPr>
@@ -40375,7 +40590,7 @@
       </p:sp>
       <p:sp>
         <p:nvSpPr>
-          <p:cNvPr id="15" name="Rectangle 14"/>
+          <p:cNvPr id="16" name="Rectangle 15"/>
           <p:cNvSpPr/>
           <p:nvPr/>
         </p:nvSpPr>
@@ -40418,7 +40633,7 @@
       </p:sp>
       <p:sp>
         <p:nvSpPr>
-          <p:cNvPr id="16" name="Rectangle 15"/>
+          <p:cNvPr id="17" name="Rectangle 16"/>
           <p:cNvSpPr/>
           <p:nvPr/>
         </p:nvSpPr>
@@ -40461,7 +40676,7 @@
       </p:sp>
       <p:sp>
         <p:nvSpPr>
-          <p:cNvPr id="17" name="Rectangle 16"/>
+          <p:cNvPr id="18" name="Rectangle 17"/>
           <p:cNvSpPr/>
           <p:nvPr/>
         </p:nvSpPr>
@@ -40504,7 +40719,7 @@
       </p:sp>
       <p:sp>
         <p:nvSpPr>
-          <p:cNvPr id="18" name="Arc 17"/>
+          <p:cNvPr id="19" name="Arc 18"/>
           <p:cNvSpPr/>
           <p:nvPr/>
         </p:nvSpPr>
@@ -40547,7 +40762,7 @@
       </p:sp>
       <p:sp>
         <p:nvSpPr>
-          <p:cNvPr id="19" name="Rectangle 18"/>
+          <p:cNvPr id="20" name="Rectangle 19"/>
           <p:cNvSpPr/>
           <p:nvPr/>
         </p:nvSpPr>
@@ -40590,7 +40805,7 @@
       </p:sp>
       <p:sp>
         <p:nvSpPr>
-          <p:cNvPr id="20" name="Rectangle 19"/>
+          <p:cNvPr id="21" name="Rectangle 20"/>
           <p:cNvSpPr/>
           <p:nvPr/>
         </p:nvSpPr>
@@ -40633,7 +40848,7 @@
       </p:sp>
       <p:sp>
         <p:nvSpPr>
-          <p:cNvPr id="21" name="Rectangle 20"/>
+          <p:cNvPr id="22" name="Rectangle 21"/>
           <p:cNvSpPr/>
           <p:nvPr/>
         </p:nvSpPr>
@@ -40676,7 +40891,7 @@
       </p:sp>
       <p:sp>
         <p:nvSpPr>
-          <p:cNvPr id="22" name="Rectangle 21"/>
+          <p:cNvPr id="23" name="Rectangle 22"/>
           <p:cNvSpPr/>
           <p:nvPr/>
         </p:nvSpPr>
@@ -40719,7 +40934,7 @@
       </p:sp>
       <p:sp>
         <p:nvSpPr>
-          <p:cNvPr id="23" name="TextBox 22"/>
+          <p:cNvPr id="24" name="TextBox 23"/>
           <p:cNvSpPr txBox="1"/>
           <p:nvPr/>
         </p:nvSpPr>
@@ -40753,7 +40968,7 @@
       </p:sp>
       <p:sp>
         <p:nvSpPr>
-          <p:cNvPr id="24" name="Rectangle 23"/>
+          <p:cNvPr id="25" name="Rectangle 24"/>
           <p:cNvSpPr/>
           <p:nvPr/>
         </p:nvSpPr>
@@ -40796,7 +41011,7 @@
       </p:sp>
       <p:sp>
         <p:nvSpPr>
-          <p:cNvPr id="25" name="Rounded Rectangle 24"/>
+          <p:cNvPr id="26" name="Rounded Rectangle 25"/>
           <p:cNvSpPr/>
           <p:nvPr/>
         </p:nvSpPr>
@@ -40841,7 +41056,7 @@
       </p:sp>
       <p:sp>
         <p:nvSpPr>
-          <p:cNvPr id="26" name="Rounded Rectangle 25"/>
+          <p:cNvPr id="27" name="Rounded Rectangle 26"/>
           <p:cNvSpPr/>
           <p:nvPr/>
         </p:nvSpPr>
@@ -40888,7 +41103,7 @@
       </p:sp>
       <p:sp>
         <p:nvSpPr>
-          <p:cNvPr id="27" name="Rounded Rectangle 26"/>
+          <p:cNvPr id="28" name="Rounded Rectangle 27"/>
           <p:cNvSpPr/>
           <p:nvPr/>
         </p:nvSpPr>
@@ -40940,7 +41155,7 @@
       </p:sp>
       <p:sp>
         <p:nvSpPr>
-          <p:cNvPr id="28" name="TextBox 27"/>
+          <p:cNvPr id="29" name="TextBox 28"/>
           <p:cNvSpPr txBox="1"/>
           <p:nvPr/>
         </p:nvSpPr>
@@ -41075,7 +41290,7 @@
       </p:sp>
       <p:sp>
         <p:nvSpPr>
-          <p:cNvPr id="29" name="Rounded Rectangle 28"/>
+          <p:cNvPr id="30" name="Rounded Rectangle 29"/>
           <p:cNvSpPr/>
           <p:nvPr/>
         </p:nvSpPr>
@@ -41120,7 +41335,7 @@
       </p:sp>
       <p:sp>
         <p:nvSpPr>
-          <p:cNvPr id="30" name="Rounded Rectangle 29"/>
+          <p:cNvPr id="31" name="Rounded Rectangle 30"/>
           <p:cNvSpPr/>
           <p:nvPr/>
         </p:nvSpPr>
@@ -41176,7 +41391,7 @@
       </p:sp>
       <p:sp>
         <p:nvSpPr>
-          <p:cNvPr id="31" name="Rounded Rectangle 30"/>
+          <p:cNvPr id="32" name="Rounded Rectangle 31"/>
           <p:cNvSpPr/>
           <p:nvPr/>
         </p:nvSpPr>
@@ -41221,7 +41436,7 @@
       </p:sp>
       <p:sp>
         <p:nvSpPr>
-          <p:cNvPr id="32" name="Rectangle 31"/>
+          <p:cNvPr id="33" name="Rectangle 32"/>
           <p:cNvSpPr/>
           <p:nvPr/>
         </p:nvSpPr>
@@ -41264,7 +41479,7 @@
       </p:sp>
       <p:sp>
         <p:nvSpPr>
-          <p:cNvPr id="33" name="Rectangle 32"/>
+          <p:cNvPr id="34" name="Rectangle 33"/>
           <p:cNvSpPr/>
           <p:nvPr/>
         </p:nvSpPr>
@@ -41307,7 +41522,7 @@
       </p:sp>
       <p:sp>
         <p:nvSpPr>
-          <p:cNvPr id="34" name="Rectangle 33"/>
+          <p:cNvPr id="35" name="Rectangle 34"/>
           <p:cNvSpPr/>
           <p:nvPr/>
         </p:nvSpPr>
@@ -41350,7 +41565,7 @@
       </p:sp>
       <p:sp>
         <p:nvSpPr>
-          <p:cNvPr id="35" name="Rectangle 34"/>
+          <p:cNvPr id="36" name="Rectangle 35"/>
           <p:cNvSpPr/>
           <p:nvPr/>
         </p:nvSpPr>
@@ -41393,7 +41608,7 @@
       </p:sp>
       <p:sp>
         <p:nvSpPr>
-          <p:cNvPr id="36" name="Rectangle 35"/>
+          <p:cNvPr id="37" name="Rectangle 36"/>
           <p:cNvSpPr/>
           <p:nvPr/>
         </p:nvSpPr>
@@ -41436,7 +41651,7 @@
       </p:sp>
       <p:sp>
         <p:nvSpPr>
-          <p:cNvPr id="37" name="Rectangle 36"/>
+          <p:cNvPr id="38" name="Rectangle 37"/>
           <p:cNvSpPr/>
           <p:nvPr/>
         </p:nvSpPr>
@@ -41479,7 +41694,7 @@
       </p:sp>
       <p:sp>
         <p:nvSpPr>
-          <p:cNvPr id="38" name="Rectangle 37"/>
+          <p:cNvPr id="39" name="Rectangle 38"/>
           <p:cNvSpPr/>
           <p:nvPr/>
         </p:nvSpPr>
@@ -41522,7 +41737,7 @@
       </p:sp>
       <p:sp>
         <p:nvSpPr>
-          <p:cNvPr id="39" name="TextBox 38"/>
+          <p:cNvPr id="40" name="TextBox 39"/>
           <p:cNvSpPr txBox="1"/>
           <p:nvPr/>
         </p:nvSpPr>
@@ -41556,7 +41771,7 @@
       </p:sp>
       <p:sp>
         <p:nvSpPr>
-          <p:cNvPr id="40" name="Rectangle 39"/>
+          <p:cNvPr id="41" name="Rectangle 40"/>
           <p:cNvSpPr/>
           <p:nvPr/>
         </p:nvSpPr>
@@ -41599,7 +41814,7 @@
       </p:sp>
       <p:sp>
         <p:nvSpPr>
-          <p:cNvPr id="41" name="TextBox 40"/>
+          <p:cNvPr id="42" name="TextBox 41"/>
           <p:cNvSpPr txBox="1"/>
           <p:nvPr/>
         </p:nvSpPr>
@@ -41633,7 +41848,7 @@
       </p:sp>
       <p:sp>
         <p:nvSpPr>
-          <p:cNvPr id="42" name="Rectangle 41"/>
+          <p:cNvPr id="43" name="Rectangle 42"/>
           <p:cNvSpPr/>
           <p:nvPr/>
         </p:nvSpPr>
@@ -41676,7 +41891,7 @@
       </p:sp>
       <p:sp>
         <p:nvSpPr>
-          <p:cNvPr id="43" name="Arc 42"/>
+          <p:cNvPr id="44" name="Arc 43"/>
           <p:cNvSpPr/>
           <p:nvPr/>
         </p:nvSpPr>
@@ -41719,7 +41934,7 @@
       </p:sp>
       <p:sp>
         <p:nvSpPr>
-          <p:cNvPr id="44" name="Rectangle 43"/>
+          <p:cNvPr id="45" name="Rectangle 44"/>
           <p:cNvSpPr/>
           <p:nvPr/>
         </p:nvSpPr>
@@ -41762,7 +41977,7 @@
       </p:sp>
       <p:sp>
         <p:nvSpPr>
-          <p:cNvPr id="45" name="TextBox 44"/>
+          <p:cNvPr id="46" name="TextBox 45"/>
           <p:cNvSpPr txBox="1"/>
           <p:nvPr/>
         </p:nvSpPr>
@@ -41796,7 +42011,7 @@
       </p:sp>
       <p:sp>
         <p:nvSpPr>
-          <p:cNvPr id="46" name="TextBox 45"/>
+          <p:cNvPr id="47" name="TextBox 46"/>
           <p:cNvSpPr txBox="1"/>
           <p:nvPr/>
         </p:nvSpPr>
@@ -41857,7 +42072,7 @@
       <p:grpSpPr/>
       <p:pic>
         <p:nvPicPr>
-          <p:cNvPr id="2" name="Picture 1" descr="tech-bg-7.jpg"/>
+          <p:cNvPr id="2" name="Picture 1" descr="scene-07.jpg"/>
           <p:cNvPicPr>
             <a:picLocks noChangeAspect="1"/>
           </p:cNvPicPr>
@@ -41871,8 +42086,8 @@
         </p:blipFill>
         <p:spPr>
           <a:xfrm>
-            <a:off x="0" y="0"/>
-            <a:ext cx="12191695" cy="6858000"/>
+            <a:off x="7818120" y="0"/>
+            <a:ext cx="4370832" cy="6858000"/>
           </a:xfrm>
           <a:prstGeom prst="rect">
             <a:avLst/>
@@ -41887,8 +42102,8 @@
         </p:nvSpPr>
         <p:spPr>
           <a:xfrm>
-            <a:off x="0" y="0"/>
-            <a:ext cx="12191695" cy="6858000"/>
+            <a:off x="7699248" y="0"/>
+            <a:ext cx="4526280" cy="6858000"/>
           </a:xfrm>
           <a:prstGeom prst="rect">
             <a:avLst/>
@@ -44204,7 +44419,7 @@
       <p:grpSpPr/>
       <p:pic>
         <p:nvPicPr>
-          <p:cNvPr id="2" name="Picture 1" descr="tech-bg-8.jpg"/>
+          <p:cNvPr id="2" name="Picture 1" descr="scene-08.jpg"/>
           <p:cNvPicPr>
             <a:picLocks noChangeAspect="1"/>
           </p:cNvPicPr>
@@ -46276,7 +46491,7 @@
       <p:grpSpPr/>
       <p:pic>
         <p:nvPicPr>
-          <p:cNvPr id="2" name="Picture 1" descr="tech-bg-1.jpg"/>
+          <p:cNvPr id="2" name="Picture 1" descr="scene-09.jpg"/>
           <p:cNvPicPr>
             <a:picLocks noChangeAspect="1"/>
           </p:cNvPicPr>
@@ -46290,28 +46505,114 @@
         </p:blipFill>
         <p:spPr>
           <a:xfrm>
+            <a:off x="4754880" y="0"/>
+            <a:ext cx="7452360" cy="6858000"/>
+          </a:xfrm>
+          <a:prstGeom prst="rect">
+            <a:avLst/>
+          </a:prstGeom>
+        </p:spPr>
+      </p:pic>
+      <p:sp>
+        <p:nvSpPr>
+          <p:cNvPr id="3" name="Chevron 2"/>
+          <p:cNvSpPr/>
+          <p:nvPr/>
+        </p:nvSpPr>
+        <p:spPr>
+          <a:xfrm>
+            <a:off x="4434840" y="45720"/>
+            <a:ext cx="2423160" cy="6720840"/>
+          </a:xfrm>
+          <a:prstGeom prst="chevron">
+            <a:avLst/>
+          </a:prstGeom>
+          <a:solidFill>
+            <a:srgbClr val="E6EEFA"/>
+          </a:solidFill>
+          <a:ln>
+            <a:noFill/>
+          </a:ln>
+        </p:spPr>
+        <p:style>
+          <a:lnRef idx="1">
+            <a:schemeClr val="accent1"/>
+          </a:lnRef>
+          <a:fillRef idx="3">
+            <a:schemeClr val="accent1"/>
+          </a:fillRef>
+          <a:effectRef idx="2">
+            <a:schemeClr val="accent1"/>
+          </a:effectRef>
+          <a:fontRef idx="minor">
+            <a:schemeClr val="lt1"/>
+          </a:fontRef>
+        </p:style>
+        <p:txBody>
+          <a:bodyPr rtlCol="0" anchor="ctr"/>
+          <a:lstStyle/>
+          <a:p>
+            <a:pPr algn="ctr"/>
+          </a:p>
+        </p:txBody>
+      </p:sp>
+      <p:sp>
+        <p:nvSpPr>
+          <p:cNvPr id="4" name="Rectangle 3"/>
+          <p:cNvSpPr/>
+          <p:nvPr/>
+        </p:nvSpPr>
+        <p:spPr>
+          <a:xfrm>
+            <a:off x="4663440" y="0"/>
+            <a:ext cx="7543800" cy="6858000"/>
+          </a:xfrm>
+          <a:prstGeom prst="rect">
+            <a:avLst/>
+          </a:prstGeom>
+          <a:solidFill>
+            <a:srgbClr val="FFFFFF"/>
+          </a:solidFill>
+          <a:ln>
+            <a:noFill/>
+          </a:ln>
+        </p:spPr>
+        <p:style>
+          <a:lnRef idx="1">
+            <a:schemeClr val="accent1"/>
+          </a:lnRef>
+          <a:fillRef idx="3">
+            <a:schemeClr val="accent1"/>
+          </a:fillRef>
+          <a:effectRef idx="2">
+            <a:schemeClr val="accent1"/>
+          </a:effectRef>
+          <a:fontRef idx="minor">
+            <a:schemeClr val="lt1"/>
+          </a:fontRef>
+        </p:style>
+        <p:txBody>
+          <a:bodyPr rtlCol="0" anchor="ctr"/>
+          <a:lstStyle/>
+          <a:p>
+            <a:pPr algn="ctr"/>
+          </a:p>
+        </p:txBody>
+      </p:sp>
+      <p:sp>
+        <p:nvSpPr>
+          <p:cNvPr id="5" name="Rectangle 4"/>
+          <p:cNvSpPr/>
+          <p:nvPr/>
+        </p:nvSpPr>
+        <p:spPr>
+          <a:xfrm>
             <a:off x="0" y="0"/>
             <a:ext cx="12191695" cy="6858000"/>
           </a:xfrm>
           <a:prstGeom prst="rect">
             <a:avLst/>
           </a:prstGeom>
-        </p:spPr>
-      </p:pic>
-      <p:sp>
-        <p:nvSpPr>
-          <p:cNvPr id="3" name="Rectangle 2"/>
-          <p:cNvSpPr/>
-          <p:nvPr/>
-        </p:nvSpPr>
-        <p:spPr>
-          <a:xfrm>
-            <a:off x="0" y="0"/>
-            <a:ext cx="12191695" cy="6858000"/>
-          </a:xfrm>
-          <a:prstGeom prst="rect">
-            <a:avLst/>
-          </a:prstGeom>
           <a:solidFill>
             <a:srgbClr val="FFFFFF"/>
           </a:solidFill>
@@ -46343,50 +46644,7 @@
       </p:sp>
       <p:sp>
         <p:nvSpPr>
-          <p:cNvPr id="4" name="Rectangle 3"/>
-          <p:cNvSpPr/>
-          <p:nvPr/>
-        </p:nvSpPr>
-        <p:spPr>
-          <a:xfrm>
-            <a:off x="0" y="0"/>
-            <a:ext cx="12191695" cy="6858000"/>
-          </a:xfrm>
-          <a:prstGeom prst="rect">
-            <a:avLst/>
-          </a:prstGeom>
-          <a:solidFill>
-            <a:srgbClr val="FFFFFF"/>
-          </a:solidFill>
-          <a:ln>
-            <a:noFill/>
-          </a:ln>
-        </p:spPr>
-        <p:style>
-          <a:lnRef idx="1">
-            <a:schemeClr val="accent1"/>
-          </a:lnRef>
-          <a:fillRef idx="3">
-            <a:schemeClr val="accent1"/>
-          </a:fillRef>
-          <a:effectRef idx="2">
-            <a:schemeClr val="accent1"/>
-          </a:effectRef>
-          <a:fontRef idx="minor">
-            <a:schemeClr val="lt1"/>
-          </a:fontRef>
-        </p:style>
-        <p:txBody>
-          <a:bodyPr rtlCol="0" anchor="ctr"/>
-          <a:lstStyle/>
-          <a:p>
-            <a:pPr algn="ctr"/>
-          </a:p>
-        </p:txBody>
-      </p:sp>
-      <p:sp>
-        <p:nvSpPr>
-          <p:cNvPr id="5" name="Rectangle 4"/>
+          <p:cNvPr id="6" name="Rectangle 5"/>
           <p:cNvSpPr/>
           <p:nvPr/>
         </p:nvSpPr>
@@ -46429,7 +46687,7 @@
       </p:sp>
       <p:sp>
         <p:nvSpPr>
-          <p:cNvPr id="6" name="Rectangle 5"/>
+          <p:cNvPr id="7" name="Rectangle 6"/>
           <p:cNvSpPr/>
           <p:nvPr/>
         </p:nvSpPr>
@@ -46472,7 +46730,7 @@
       </p:sp>
       <p:sp>
         <p:nvSpPr>
-          <p:cNvPr id="7" name="Rectangle 6"/>
+          <p:cNvPr id="8" name="Rectangle 7"/>
           <p:cNvSpPr/>
           <p:nvPr/>
         </p:nvSpPr>
@@ -46515,7 +46773,7 @@
       </p:sp>
       <p:sp>
         <p:nvSpPr>
-          <p:cNvPr id="8" name="Rectangle 7"/>
+          <p:cNvPr id="9" name="Rectangle 8"/>
           <p:cNvSpPr/>
           <p:nvPr/>
         </p:nvSpPr>
@@ -46558,7 +46816,7 @@
       </p:sp>
       <p:sp>
         <p:nvSpPr>
-          <p:cNvPr id="9" name="Oval 8"/>
+          <p:cNvPr id="10" name="Oval 9"/>
           <p:cNvSpPr/>
           <p:nvPr/>
         </p:nvSpPr>
@@ -46601,7 +46859,7 @@
       </p:sp>
       <p:sp>
         <p:nvSpPr>
-          <p:cNvPr id="10" name="Oval 9"/>
+          <p:cNvPr id="11" name="Oval 10"/>
           <p:cNvSpPr/>
           <p:nvPr/>
         </p:nvSpPr>
@@ -46644,7 +46902,7 @@
       </p:sp>
       <p:sp>
         <p:nvSpPr>
-          <p:cNvPr id="11" name="Rectangle 10"/>
+          <p:cNvPr id="12" name="Rectangle 11"/>
           <p:cNvSpPr/>
           <p:nvPr/>
         </p:nvSpPr>
@@ -46687,7 +46945,7 @@
       </p:sp>
       <p:sp>
         <p:nvSpPr>
-          <p:cNvPr id="12" name="Rectangle 11"/>
+          <p:cNvPr id="13" name="Rectangle 12"/>
           <p:cNvSpPr/>
           <p:nvPr/>
         </p:nvSpPr>
@@ -46730,7 +46988,7 @@
       </p:sp>
       <p:sp>
         <p:nvSpPr>
-          <p:cNvPr id="13" name="Rectangle 12"/>
+          <p:cNvPr id="14" name="Rectangle 13"/>
           <p:cNvSpPr/>
           <p:nvPr/>
         </p:nvSpPr>
@@ -46773,7 +47031,7 @@
       </p:sp>
       <p:sp>
         <p:nvSpPr>
-          <p:cNvPr id="14" name="Rectangle 13"/>
+          <p:cNvPr id="15" name="Rectangle 14"/>
           <p:cNvSpPr/>
           <p:nvPr/>
         </p:nvSpPr>
@@ -46816,7 +47074,7 @@
       </p:sp>
       <p:sp>
         <p:nvSpPr>
-          <p:cNvPr id="15" name="Rectangle 14"/>
+          <p:cNvPr id="16" name="Rectangle 15"/>
           <p:cNvSpPr/>
           <p:nvPr/>
         </p:nvSpPr>
@@ -46859,7 +47117,7 @@
       </p:sp>
       <p:sp>
         <p:nvSpPr>
-          <p:cNvPr id="16" name="Rectangle 15"/>
+          <p:cNvPr id="17" name="Rectangle 16"/>
           <p:cNvSpPr/>
           <p:nvPr/>
         </p:nvSpPr>
@@ -46902,7 +47160,7 @@
       </p:sp>
       <p:sp>
         <p:nvSpPr>
-          <p:cNvPr id="17" name="Rectangle 16"/>
+          <p:cNvPr id="18" name="Rectangle 17"/>
           <p:cNvSpPr/>
           <p:nvPr/>
         </p:nvSpPr>
@@ -46945,7 +47203,7 @@
       </p:sp>
       <p:sp>
         <p:nvSpPr>
-          <p:cNvPr id="18" name="Arc 17"/>
+          <p:cNvPr id="19" name="Arc 18"/>
           <p:cNvSpPr/>
           <p:nvPr/>
         </p:nvSpPr>
@@ -46988,7 +47246,7 @@
       </p:sp>
       <p:sp>
         <p:nvSpPr>
-          <p:cNvPr id="19" name="Rectangle 18"/>
+          <p:cNvPr id="20" name="Rectangle 19"/>
           <p:cNvSpPr/>
           <p:nvPr/>
         </p:nvSpPr>
@@ -47031,7 +47289,7 @@
       </p:sp>
       <p:sp>
         <p:nvSpPr>
-          <p:cNvPr id="20" name="Rectangle 19"/>
+          <p:cNvPr id="21" name="Rectangle 20"/>
           <p:cNvSpPr/>
           <p:nvPr/>
         </p:nvSpPr>
@@ -47074,7 +47332,7 @@
       </p:sp>
       <p:sp>
         <p:nvSpPr>
-          <p:cNvPr id="21" name="Rectangle 20"/>
+          <p:cNvPr id="22" name="Rectangle 21"/>
           <p:cNvSpPr/>
           <p:nvPr/>
         </p:nvSpPr>
@@ -47117,7 +47375,7 @@
       </p:sp>
       <p:sp>
         <p:nvSpPr>
-          <p:cNvPr id="22" name="Rectangle 21"/>
+          <p:cNvPr id="23" name="Rectangle 22"/>
           <p:cNvSpPr/>
           <p:nvPr/>
         </p:nvSpPr>
@@ -47160,7 +47418,7 @@
       </p:sp>
       <p:sp>
         <p:nvSpPr>
-          <p:cNvPr id="23" name="TextBox 22"/>
+          <p:cNvPr id="24" name="TextBox 23"/>
           <p:cNvSpPr txBox="1"/>
           <p:nvPr/>
         </p:nvSpPr>
@@ -47194,7 +47452,7 @@
       </p:sp>
       <p:sp>
         <p:nvSpPr>
-          <p:cNvPr id="24" name="Rectangle 23"/>
+          <p:cNvPr id="25" name="Rectangle 24"/>
           <p:cNvSpPr/>
           <p:nvPr/>
         </p:nvSpPr>
@@ -47237,7 +47495,7 @@
       </p:sp>
       <p:sp>
         <p:nvSpPr>
-          <p:cNvPr id="25" name="Rounded Rectangle 24"/>
+          <p:cNvPr id="26" name="Rounded Rectangle 25"/>
           <p:cNvSpPr/>
           <p:nvPr/>
         </p:nvSpPr>
@@ -47282,7 +47540,7 @@
       </p:sp>
       <p:sp>
         <p:nvSpPr>
-          <p:cNvPr id="26" name="Rounded Rectangle 25"/>
+          <p:cNvPr id="27" name="Rounded Rectangle 26"/>
           <p:cNvSpPr/>
           <p:nvPr/>
         </p:nvSpPr>
@@ -47329,7 +47587,7 @@
       </p:sp>
       <p:sp>
         <p:nvSpPr>
-          <p:cNvPr id="27" name="Rounded Rectangle 26"/>
+          <p:cNvPr id="28" name="Rounded Rectangle 27"/>
           <p:cNvSpPr/>
           <p:nvPr/>
         </p:nvSpPr>
@@ -47381,7 +47639,7 @@
       </p:sp>
       <p:sp>
         <p:nvSpPr>
-          <p:cNvPr id="28" name="TextBox 27"/>
+          <p:cNvPr id="29" name="TextBox 28"/>
           <p:cNvSpPr txBox="1"/>
           <p:nvPr/>
         </p:nvSpPr>
@@ -47532,7 +47790,7 @@
       </p:sp>
       <p:sp>
         <p:nvSpPr>
-          <p:cNvPr id="29" name="Rounded Rectangle 28"/>
+          <p:cNvPr id="30" name="Rounded Rectangle 29"/>
           <p:cNvSpPr/>
           <p:nvPr/>
         </p:nvSpPr>
@@ -47577,7 +47835,7 @@
       </p:sp>
       <p:sp>
         <p:nvSpPr>
-          <p:cNvPr id="30" name="Rounded Rectangle 29"/>
+          <p:cNvPr id="31" name="Rounded Rectangle 30"/>
           <p:cNvSpPr/>
           <p:nvPr/>
         </p:nvSpPr>
@@ -47633,7 +47891,7 @@
       </p:sp>
       <p:sp>
         <p:nvSpPr>
-          <p:cNvPr id="31" name="Rounded Rectangle 30"/>
+          <p:cNvPr id="32" name="Rounded Rectangle 31"/>
           <p:cNvSpPr/>
           <p:nvPr/>
         </p:nvSpPr>
@@ -47678,7 +47936,7 @@
       </p:sp>
       <p:sp>
         <p:nvSpPr>
-          <p:cNvPr id="32" name="Rectangle 31"/>
+          <p:cNvPr id="33" name="Rectangle 32"/>
           <p:cNvSpPr/>
           <p:nvPr/>
         </p:nvSpPr>
@@ -47721,7 +47979,7 @@
       </p:sp>
       <p:sp>
         <p:nvSpPr>
-          <p:cNvPr id="33" name="Rectangle 32"/>
+          <p:cNvPr id="34" name="Rectangle 33"/>
           <p:cNvSpPr/>
           <p:nvPr/>
         </p:nvSpPr>
@@ -47764,7 +48022,7 @@
       </p:sp>
       <p:sp>
         <p:nvSpPr>
-          <p:cNvPr id="34" name="Rectangle 33"/>
+          <p:cNvPr id="35" name="Rectangle 34"/>
           <p:cNvSpPr/>
           <p:nvPr/>
         </p:nvSpPr>
@@ -47807,7 +48065,7 @@
       </p:sp>
       <p:sp>
         <p:nvSpPr>
-          <p:cNvPr id="35" name="Rectangle 34"/>
+          <p:cNvPr id="36" name="Rectangle 35"/>
           <p:cNvSpPr/>
           <p:nvPr/>
         </p:nvSpPr>
@@ -47850,7 +48108,7 @@
       </p:sp>
       <p:sp>
         <p:nvSpPr>
-          <p:cNvPr id="36" name="Rectangle 35"/>
+          <p:cNvPr id="37" name="Rectangle 36"/>
           <p:cNvSpPr/>
           <p:nvPr/>
         </p:nvSpPr>
@@ -47893,7 +48151,7 @@
       </p:sp>
       <p:sp>
         <p:nvSpPr>
-          <p:cNvPr id="37" name="Rectangle 36"/>
+          <p:cNvPr id="38" name="Rectangle 37"/>
           <p:cNvSpPr/>
           <p:nvPr/>
         </p:nvSpPr>
@@ -47936,7 +48194,7 @@
       </p:sp>
       <p:sp>
         <p:nvSpPr>
-          <p:cNvPr id="38" name="Rectangle 37"/>
+          <p:cNvPr id="39" name="Rectangle 38"/>
           <p:cNvSpPr/>
           <p:nvPr/>
         </p:nvSpPr>
@@ -47979,7 +48237,7 @@
       </p:sp>
       <p:sp>
         <p:nvSpPr>
-          <p:cNvPr id="39" name="TextBox 38"/>
+          <p:cNvPr id="40" name="TextBox 39"/>
           <p:cNvSpPr txBox="1"/>
           <p:nvPr/>
         </p:nvSpPr>
@@ -48013,7 +48271,7 @@
       </p:sp>
       <p:sp>
         <p:nvSpPr>
-          <p:cNvPr id="40" name="Rectangle 39"/>
+          <p:cNvPr id="41" name="Rectangle 40"/>
           <p:cNvSpPr/>
           <p:nvPr/>
         </p:nvSpPr>
@@ -48056,7 +48314,7 @@
       </p:sp>
       <p:sp>
         <p:nvSpPr>
-          <p:cNvPr id="41" name="TextBox 40"/>
+          <p:cNvPr id="42" name="TextBox 41"/>
           <p:cNvSpPr txBox="1"/>
           <p:nvPr/>
         </p:nvSpPr>
@@ -48090,7 +48348,7 @@
       </p:sp>
       <p:sp>
         <p:nvSpPr>
-          <p:cNvPr id="42" name="Rectangle 41"/>
+          <p:cNvPr id="43" name="Rectangle 42"/>
           <p:cNvSpPr/>
           <p:nvPr/>
         </p:nvSpPr>
@@ -48133,7 +48391,7 @@
       </p:sp>
       <p:sp>
         <p:nvSpPr>
-          <p:cNvPr id="43" name="Arc 42"/>
+          <p:cNvPr id="44" name="Arc 43"/>
           <p:cNvSpPr/>
           <p:nvPr/>
         </p:nvSpPr>
@@ -48176,7 +48434,7 @@
       </p:sp>
       <p:sp>
         <p:nvSpPr>
-          <p:cNvPr id="44" name="Rectangle 43"/>
+          <p:cNvPr id="45" name="Rectangle 44"/>
           <p:cNvSpPr/>
           <p:nvPr/>
         </p:nvSpPr>
@@ -48219,7 +48477,7 @@
       </p:sp>
       <p:sp>
         <p:nvSpPr>
-          <p:cNvPr id="45" name="TextBox 44"/>
+          <p:cNvPr id="46" name="TextBox 45"/>
           <p:cNvSpPr txBox="1"/>
           <p:nvPr/>
         </p:nvSpPr>
@@ -48253,7 +48511,7 @@
       </p:sp>
       <p:sp>
         <p:nvSpPr>
-          <p:cNvPr id="46" name="TextBox 45"/>
+          <p:cNvPr id="47" name="TextBox 46"/>
           <p:cNvSpPr txBox="1"/>
           <p:nvPr/>
         </p:nvSpPr>

</xml_diff>